<commit_message>
WIP: PT-03 standoff set at the face-to-face gap convention; PT-04 to PT-07 and decks regenerating (agent snapshot)
Co-Authored-By: Claude Fable 5.1 <noreply@anthropic.com>
Claude-Session: https://claude.ai/code/session_01ERsPi9xhFu3U1nLCkBXPjN
</commit_message>
<xml_diff>
--- a/docs/presentations/vsx3000_test_procedure.pptx
+++ b/docs/presentations/vsx3000_test_procedure.pptx
@@ -126,7 +126,7 @@
   <p:extLst>
     <p:ext uri="{521415D9-36F7-43E2-AB2F-B90AF26B5E84}">
       <p14:sectionLst xmlns:p14="http://schemas.microsoft.com/office/powerpoint/2010/main">
-        <p14:section name="Introduction" id="{37161144-b57f-7ff4-d79d-54df33b7184a}">
+        <p14:section name="Introduction" id="{b47bdf1e-3234-2fc1-4060-1f73d612e30f}">
           <p14:sldIdLst>
             <p14:sldId id="256"/>
             <p14:sldId id="257"/>
@@ -135,7 +135,7 @@
             <p14:sldId id="260"/>
           </p14:sldIdLst>
         </p14:section>
-        <p14:section name="Setup" id="{0f432cbc-ce5d-031c-288a-1715942cf00b}">
+        <p14:section name="Setup" id="{a1259c43-a2d4-3fce-bdeb-4ac74c8d490e}">
           <p14:sldIdLst>
             <p14:sldId id="261"/>
             <p14:sldId id="262"/>
@@ -143,7 +143,7 @@
             <p14:sldId id="264"/>
           </p14:sldIdLst>
         </p14:section>
-        <p14:section name="Capture" id="{1ac7fca2-c525-463d-bce7-57ae6f22af18}">
+        <p14:section name="Capture" id="{088ff3ff-8720-6c12-b38d-71f1584abf5d}">
           <p14:sldIdLst>
             <p14:sldId id="265"/>
             <p14:sldId id="266"/>
@@ -155,12 +155,12 @@
             <p14:sldId id="272"/>
           </p14:sldIdLst>
         </p14:section>
-        <p14:section name="Checks" id="{55d5dd3e-45f7-1c52-cbf2-b2b170fe9479}">
+        <p14:section name="Checks" id="{68e082f9-5972-308a-5235-31ff36fcf61c}">
           <p14:sldIdLst>
             <p14:sldId id="273"/>
           </p14:sldIdLst>
         </p14:section>
-        <p14:section name="Wrap-up" id="{b850ad00-89ac-9313-ce06-0c6c61063327}">
+        <p14:section name="Wrap-up" id="{1947572c-7964-0bb5-c25b-58ac8acfe25a}">
           <p14:sldIdLst>
             <p14:sldId id="274"/>
             <p14:sldId id="275"/>
@@ -6110,11 +6110,11 @@
         <p:spPr>
           <a:xfrm>
             <a:off x="457200" y="1417320"/>
-            <a:ext cx="5501488" cy="1943100"/>
+            <a:ext cx="5501488" cy="2295144"/>
           </a:xfrm>
           <a:prstGeom prst="roundRect">
             <a:avLst>
-              <a:gd name="adj" fmla="val 5647"/>
+              <a:gd name="adj" fmla="val 4781"/>
             </a:avLst>
           </a:prstGeom>
           <a:solidFill>
@@ -6143,14 +6143,14 @@
             <a:avLst/>
           </a:prstGeom>
           <a:solidFill>
-            <a:schemeClr val="accent4"/>
+            <a:schemeClr val="accent2"/>
           </a:solidFill>
           <a:ln/>
         </p:spPr>
       </p:sp>
       <p:pic>
         <p:nvPicPr>
-          <p:cNvPr id="5" name="Check 1 icon glyph" descr="warning icon">    </p:cNvPr>
+          <p:cNvPr id="5" name="Check 1 icon glyph" descr="gauge icon">    </p:cNvPr>
           <p:cNvPicPr>
             <a:picLocks noChangeAspect="1"/>
           </p:cNvPicPr>
@@ -6181,7 +6181,7 @@
         <p:spPr>
           <a:xfrm>
             <a:off x="1463040" y="1600200"/>
-            <a:ext cx="4312768" cy="1577340"/>
+            <a:ext cx="4312768" cy="1929384"/>
           </a:xfrm>
           <a:prstGeom prst="rect">
             <a:avLst/>
@@ -6251,11 +6251,11 @@
         <p:spPr>
           <a:xfrm>
             <a:off x="6233008" y="1417320"/>
-            <a:ext cx="5501488" cy="1943100"/>
+            <a:ext cx="5501488" cy="2295144"/>
           </a:xfrm>
           <a:prstGeom prst="roundRect">
             <a:avLst>
-              <a:gd name="adj" fmla="val 5647"/>
+              <a:gd name="adj" fmla="val 4781"/>
             </a:avLst>
           </a:prstGeom>
           <a:solidFill>
@@ -6284,14 +6284,14 @@
             <a:avLst/>
           </a:prstGeom>
           <a:solidFill>
-            <a:schemeClr val="accent4"/>
+            <a:schemeClr val="accent2"/>
           </a:solidFill>
           <a:ln/>
         </p:spPr>
       </p:sp>
       <p:pic>
         <p:nvPicPr>
-          <p:cNvPr id="9" name="Check 2 icon glyph" descr="warning icon">    </p:cNvPr>
+          <p:cNvPr id="9" name="Check 2 icon glyph" descr="ruler icon">    </p:cNvPr>
           <p:cNvPicPr>
             <a:picLocks noChangeAspect="1"/>
           </p:cNvPicPr>
@@ -6322,7 +6322,7 @@
         <p:spPr>
           <a:xfrm>
             <a:off x="7238848" y="1600200"/>
-            <a:ext cx="4312768" cy="1577340"/>
+            <a:ext cx="4312768" cy="1929384"/>
           </a:xfrm>
           <a:prstGeom prst="rect">
             <a:avLst/>
@@ -6391,12 +6391,12 @@
         </p:nvSpPr>
         <p:spPr>
           <a:xfrm>
-            <a:off x="457200" y="3634740"/>
-            <a:ext cx="5501488" cy="1943100"/>
+            <a:off x="457200" y="3986784"/>
+            <a:ext cx="5501488" cy="1868424"/>
           </a:xfrm>
           <a:prstGeom prst="roundRect">
             <a:avLst>
-              <a:gd name="adj" fmla="val 5647"/>
+              <a:gd name="adj" fmla="val 5873"/>
             </a:avLst>
           </a:prstGeom>
           <a:solidFill>
@@ -6418,21 +6418,21 @@
         </p:nvSpPr>
         <p:spPr>
           <a:xfrm>
-            <a:off x="640080" y="3817620"/>
+            <a:off x="640080" y="4169664"/>
             <a:ext cx="640080" cy="640080"/>
           </a:xfrm>
           <a:prstGeom prst="ellipse">
             <a:avLst/>
           </a:prstGeom>
           <a:solidFill>
-            <a:schemeClr val="accent4"/>
+            <a:schemeClr val="accent2"/>
           </a:solidFill>
           <a:ln/>
         </p:spPr>
       </p:sp>
       <p:pic>
         <p:nvPicPr>
-          <p:cNvPr id="13" name="Check 3 icon glyph" descr="warning icon">    </p:cNvPr>
+          <p:cNvPr id="13" name="Check 3 icon glyph" descr="bullseye icon">    </p:cNvPr>
           <p:cNvPicPr>
             <a:picLocks noChangeAspect="1"/>
           </p:cNvPicPr>
@@ -6446,7 +6446,7 @@
         </p:blipFill>
         <p:spPr>
           <a:xfrm>
-            <a:off x="800100" y="3977640"/>
+            <a:off x="800100" y="4329684"/>
             <a:ext cx="320040" cy="320040"/>
           </a:xfrm>
           <a:prstGeom prst="rect">
@@ -6462,8 +6462,8 @@
         </p:nvSpPr>
         <p:spPr>
           <a:xfrm>
-            <a:off x="1463040" y="3817620"/>
-            <a:ext cx="4312768" cy="1577340"/>
+            <a:off x="1463040" y="4169664"/>
+            <a:ext cx="4312768" cy="1502664"/>
           </a:xfrm>
           <a:prstGeom prst="rect">
             <a:avLst/>
@@ -6532,12 +6532,12 @@
         </p:nvSpPr>
         <p:spPr>
           <a:xfrm>
-            <a:off x="6233008" y="3634740"/>
-            <a:ext cx="5501488" cy="1943100"/>
+            <a:off x="6233008" y="3986784"/>
+            <a:ext cx="5501488" cy="1868424"/>
           </a:xfrm>
           <a:prstGeom prst="roundRect">
             <a:avLst>
-              <a:gd name="adj" fmla="val 5647"/>
+              <a:gd name="adj" fmla="val 5873"/>
             </a:avLst>
           </a:prstGeom>
           <a:solidFill>
@@ -6559,21 +6559,21 @@
         </p:nvSpPr>
         <p:spPr>
           <a:xfrm>
-            <a:off x="6415888" y="3817620"/>
+            <a:off x="6415888" y="4169664"/>
             <a:ext cx="640080" cy="640080"/>
           </a:xfrm>
           <a:prstGeom prst="ellipse">
             <a:avLst/>
           </a:prstGeom>
           <a:solidFill>
-            <a:schemeClr val="accent4"/>
+            <a:schemeClr val="accent2"/>
           </a:solidFill>
           <a:ln/>
         </p:spPr>
       </p:sp>
       <p:pic>
         <p:nvPicPr>
-          <p:cNvPr id="17" name="Check 4 icon glyph" descr="warning icon">    </p:cNvPr>
+          <p:cNvPr id="17" name="Check 4 icon glyph" descr="edit icon">    </p:cNvPr>
           <p:cNvPicPr>
             <a:picLocks noChangeAspect="1"/>
           </p:cNvPicPr>
@@ -6587,7 +6587,7 @@
         </p:blipFill>
         <p:spPr>
           <a:xfrm>
-            <a:off x="6575908" y="3977640"/>
+            <a:off x="6575908" y="4329684"/>
             <a:ext cx="320040" cy="320040"/>
           </a:xfrm>
           <a:prstGeom prst="rect">
@@ -6603,8 +6603,8 @@
         </p:nvSpPr>
         <p:spPr>
           <a:xfrm>
-            <a:off x="7238848" y="3817620"/>
-            <a:ext cx="4312768" cy="1577340"/>
+            <a:off x="7238848" y="4169664"/>
+            <a:ext cx="4312768" cy="1502664"/>
           </a:xfrm>
           <a:prstGeom prst="rect">
             <a:avLst/>
@@ -8918,11 +8918,11 @@
         <p:spPr>
           <a:xfrm>
             <a:off x="457200" y="1417320"/>
-            <a:ext cx="5501488" cy="1203960"/>
+            <a:ext cx="3576218" cy="2173224"/>
           </a:xfrm>
           <a:prstGeom prst="roundRect">
             <a:avLst>
-              <a:gd name="adj" fmla="val 9114"/>
+              <a:gd name="adj" fmla="val 5049"/>
             </a:avLst>
           </a:prstGeom>
           <a:solidFill>
@@ -8989,7 +8989,7 @@
         <p:spPr>
           <a:xfrm>
             <a:off x="1463040" y="1600200"/>
-            <a:ext cx="4312768" cy="838200"/>
+            <a:ext cx="2387498" cy="1807464"/>
           </a:xfrm>
           <a:prstGeom prst="rect">
             <a:avLst/>
@@ -9058,12 +9058,12 @@
         </p:nvSpPr>
         <p:spPr>
           <a:xfrm>
-            <a:off x="6233008" y="1417320"/>
-            <a:ext cx="5501488" cy="1203960"/>
+            <a:off x="4307738" y="1417320"/>
+            <a:ext cx="3576218" cy="2173224"/>
           </a:xfrm>
           <a:prstGeom prst="roundRect">
             <a:avLst>
-              <a:gd name="adj" fmla="val 9114"/>
+              <a:gd name="adj" fmla="val 5049"/>
             </a:avLst>
           </a:prstGeom>
           <a:solidFill>
@@ -9085,7 +9085,7 @@
         </p:nvSpPr>
         <p:spPr>
           <a:xfrm>
-            <a:off x="6415888" y="1600200"/>
+            <a:off x="4490618" y="1600200"/>
             <a:ext cx="640080" cy="640080"/>
           </a:xfrm>
           <a:prstGeom prst="ellipse">
@@ -9113,7 +9113,7 @@
         </p:blipFill>
         <p:spPr>
           <a:xfrm>
-            <a:off x="6575908" y="1760220"/>
+            <a:off x="4650638" y="1760220"/>
             <a:ext cx="320040" cy="320040"/>
           </a:xfrm>
           <a:prstGeom prst="rect">
@@ -9129,8 +9129,8 @@
         </p:nvSpPr>
         <p:spPr>
           <a:xfrm>
-            <a:off x="7238848" y="1600200"/>
-            <a:ext cx="4312768" cy="838200"/>
+            <a:off x="5313578" y="1600200"/>
+            <a:ext cx="2387498" cy="1807464"/>
           </a:xfrm>
           <a:prstGeom prst="rect">
             <a:avLst/>
@@ -9199,12 +9199,12 @@
         </p:nvSpPr>
         <p:spPr>
           <a:xfrm>
-            <a:off x="457200" y="2895600"/>
-            <a:ext cx="5501488" cy="1203960"/>
+            <a:off x="8158277" y="1417320"/>
+            <a:ext cx="3576218" cy="2173224"/>
           </a:xfrm>
           <a:prstGeom prst="roundRect">
             <a:avLst>
-              <a:gd name="adj" fmla="val 9114"/>
+              <a:gd name="adj" fmla="val 5049"/>
             </a:avLst>
           </a:prstGeom>
           <a:solidFill>
@@ -9226,7 +9226,7 @@
         </p:nvSpPr>
         <p:spPr>
           <a:xfrm>
-            <a:off x="640080" y="3078480"/>
+            <a:off x="8341157" y="1600200"/>
             <a:ext cx="640080" cy="640080"/>
           </a:xfrm>
           <a:prstGeom prst="ellipse">
@@ -9254,7 +9254,7 @@
         </p:blipFill>
         <p:spPr>
           <a:xfrm>
-            <a:off x="800100" y="3238500"/>
+            <a:off x="8501177" y="1760220"/>
             <a:ext cx="320040" cy="320040"/>
           </a:xfrm>
           <a:prstGeom prst="rect">
@@ -9270,8 +9270,8 @@
         </p:nvSpPr>
         <p:spPr>
           <a:xfrm>
-            <a:off x="1463040" y="3078480"/>
-            <a:ext cx="4312768" cy="838200"/>
+            <a:off x="9164117" y="1600200"/>
+            <a:ext cx="2387498" cy="1807464"/>
           </a:xfrm>
           <a:prstGeom prst="rect">
             <a:avLst/>
@@ -9340,12 +9340,12 @@
         </p:nvSpPr>
         <p:spPr>
           <a:xfrm>
-            <a:off x="6233008" y="2895600"/>
-            <a:ext cx="5501488" cy="1203960"/>
+            <a:off x="457200" y="3864864"/>
+            <a:ext cx="5501488" cy="1898904"/>
           </a:xfrm>
           <a:prstGeom prst="roundRect">
             <a:avLst>
-              <a:gd name="adj" fmla="val 9114"/>
+              <a:gd name="adj" fmla="val 5778"/>
             </a:avLst>
           </a:prstGeom>
           <a:solidFill>
@@ -9367,7 +9367,7 @@
         </p:nvSpPr>
         <p:spPr>
           <a:xfrm>
-            <a:off x="6415888" y="3078480"/>
+            <a:off x="640080" y="4047744"/>
             <a:ext cx="640080" cy="640080"/>
           </a:xfrm>
           <a:prstGeom prst="ellipse">
@@ -9395,7 +9395,7 @@
         </p:blipFill>
         <p:spPr>
           <a:xfrm>
-            <a:off x="6575908" y="3238500"/>
+            <a:off x="800100" y="4207764"/>
             <a:ext cx="320040" cy="320040"/>
           </a:xfrm>
           <a:prstGeom prst="rect">
@@ -9411,8 +9411,8 @@
         </p:nvSpPr>
         <p:spPr>
           <a:xfrm>
-            <a:off x="7238848" y="3078480"/>
-            <a:ext cx="4312768" cy="838200"/>
+            <a:off x="1463040" y="4047744"/>
+            <a:ext cx="4312768" cy="1533144"/>
           </a:xfrm>
           <a:prstGeom prst="rect">
             <a:avLst/>
@@ -9481,12 +9481,12 @@
         </p:nvSpPr>
         <p:spPr>
           <a:xfrm>
-            <a:off x="457200" y="4373880"/>
-            <a:ext cx="5501488" cy="1203960"/>
+            <a:off x="6233008" y="3864864"/>
+            <a:ext cx="5501488" cy="1898904"/>
           </a:xfrm>
           <a:prstGeom prst="roundRect">
             <a:avLst>
-              <a:gd name="adj" fmla="val 9114"/>
+              <a:gd name="adj" fmla="val 5778"/>
             </a:avLst>
           </a:prstGeom>
           <a:solidFill>
@@ -9508,7 +9508,7 @@
         </p:nvSpPr>
         <p:spPr>
           <a:xfrm>
-            <a:off x="640080" y="4556760"/>
+            <a:off x="6415888" y="4047744"/>
             <a:ext cx="640080" cy="640080"/>
           </a:xfrm>
           <a:prstGeom prst="ellipse">
@@ -9536,7 +9536,7 @@
         </p:blipFill>
         <p:spPr>
           <a:xfrm>
-            <a:off x="800100" y="4716780"/>
+            <a:off x="6575908" y="4207764"/>
             <a:ext cx="320040" cy="320040"/>
           </a:xfrm>
           <a:prstGeom prst="rect">
@@ -9552,8 +9552,8 @@
         </p:nvSpPr>
         <p:spPr>
           <a:xfrm>
-            <a:off x="1463040" y="4556760"/>
-            <a:ext cx="4312768" cy="838200"/>
+            <a:off x="7238848" y="4047744"/>
+            <a:ext cx="4312768" cy="1533144"/>
           </a:xfrm>
           <a:prstGeom prst="rect">
             <a:avLst/>
@@ -9622,8 +9622,8 @@
         </p:nvSpPr>
         <p:spPr>
           <a:xfrm>
-            <a:off x="457200" y="5852160"/>
-            <a:ext cx="11277295" cy="274320"/>
+            <a:off x="457200" y="5669280"/>
+            <a:ext cx="11277295" cy="457200"/>
           </a:xfrm>
           <a:prstGeom prst="rect">
             <a:avLst/>
@@ -9770,11 +9770,11 @@
         <p:spPr>
           <a:xfrm>
             <a:off x="457200" y="1417320"/>
-            <a:ext cx="5501488" cy="1040130"/>
+            <a:ext cx="5501488" cy="960120"/>
           </a:xfrm>
           <a:prstGeom prst="roundRect">
             <a:avLst>
-              <a:gd name="adj" fmla="val 10549"/>
+              <a:gd name="adj" fmla="val 11429"/>
             </a:avLst>
           </a:prstGeom>
           <a:solidFill>
@@ -9791,7 +9791,7 @@
         </p:nvSpPr>
         <p:spPr>
           <a:xfrm>
-            <a:off x="640080" y="1640205"/>
+            <a:off x="640080" y="1600200"/>
             <a:ext cx="594360" cy="594360"/>
           </a:xfrm>
           <a:prstGeom prst="ellipse">
@@ -9819,7 +9819,7 @@
         </p:blipFill>
         <p:spPr>
           <a:xfrm>
-            <a:off x="788670" y="1788795"/>
+            <a:off x="788670" y="1748790"/>
             <a:ext cx="297180" cy="297180"/>
           </a:xfrm>
           <a:prstGeom prst="rect">
@@ -9836,7 +9836,7 @@
         <p:spPr>
           <a:xfrm>
             <a:off x="1417320" y="1417320"/>
-            <a:ext cx="4358488" cy="1040130"/>
+            <a:ext cx="4358488" cy="960120"/>
           </a:xfrm>
           <a:prstGeom prst="rect">
             <a:avLst/>
@@ -9871,12 +9871,12 @@
         </p:nvSpPr>
         <p:spPr>
           <a:xfrm>
-            <a:off x="457200" y="2640330"/>
-            <a:ext cx="5501488" cy="1040130"/>
+            <a:off x="457200" y="2560320"/>
+            <a:ext cx="5501488" cy="960120"/>
           </a:xfrm>
           <a:prstGeom prst="roundRect">
             <a:avLst>
-              <a:gd name="adj" fmla="val 10549"/>
+              <a:gd name="adj" fmla="val 11429"/>
             </a:avLst>
           </a:prstGeom>
           <a:solidFill>
@@ -9893,7 +9893,7 @@
         </p:nvSpPr>
         <p:spPr>
           <a:xfrm>
-            <a:off x="640080" y="2863215"/>
+            <a:off x="640080" y="2743200"/>
             <a:ext cx="594360" cy="594360"/>
           </a:xfrm>
           <a:prstGeom prst="ellipse">
@@ -9921,7 +9921,7 @@
         </p:blipFill>
         <p:spPr>
           <a:xfrm>
-            <a:off x="788670" y="3011805"/>
+            <a:off x="788670" y="2891790"/>
             <a:ext cx="297180" cy="297180"/>
           </a:xfrm>
           <a:prstGeom prst="rect">
@@ -9937,8 +9937,8 @@
         </p:nvSpPr>
         <p:spPr>
           <a:xfrm>
-            <a:off x="1417320" y="2640330"/>
-            <a:ext cx="4358488" cy="1040130"/>
+            <a:off x="1417320" y="2560320"/>
+            <a:ext cx="4358488" cy="960120"/>
           </a:xfrm>
           <a:prstGeom prst="rect">
             <a:avLst/>
@@ -9973,7 +9973,7 @@
         </p:nvSpPr>
         <p:spPr>
           <a:xfrm>
-            <a:off x="457200" y="3863340"/>
+            <a:off x="457200" y="3703320"/>
             <a:ext cx="5501488" cy="1152144"/>
           </a:xfrm>
           <a:prstGeom prst="roundRect">
@@ -9995,7 +9995,7 @@
         </p:nvSpPr>
         <p:spPr>
           <a:xfrm>
-            <a:off x="640080" y="4142232"/>
+            <a:off x="640080" y="3982212"/>
             <a:ext cx="594360" cy="594360"/>
           </a:xfrm>
           <a:prstGeom prst="ellipse">
@@ -10023,7 +10023,7 @@
         </p:blipFill>
         <p:spPr>
           <a:xfrm>
-            <a:off x="788670" y="4290822"/>
+            <a:off x="788670" y="4130802"/>
             <a:ext cx="297180" cy="297180"/>
           </a:xfrm>
           <a:prstGeom prst="rect">
@@ -10039,7 +10039,7 @@
         </p:nvSpPr>
         <p:spPr>
           <a:xfrm>
-            <a:off x="1417320" y="3863340"/>
+            <a:off x="1417320" y="3703320"/>
             <a:ext cx="4358488" cy="1152144"/>
           </a:xfrm>
           <a:prstGeom prst="rect">
@@ -10075,7 +10075,7 @@
         </p:nvSpPr>
         <p:spPr>
           <a:xfrm>
-            <a:off x="457200" y="5198364"/>
+            <a:off x="457200" y="5038344"/>
             <a:ext cx="5501488" cy="1152144"/>
           </a:xfrm>
           <a:prstGeom prst="roundRect">
@@ -10097,7 +10097,7 @@
         </p:nvSpPr>
         <p:spPr>
           <a:xfrm>
-            <a:off x="640080" y="5477256"/>
+            <a:off x="640080" y="5317236"/>
             <a:ext cx="594360" cy="594360"/>
           </a:xfrm>
           <a:prstGeom prst="ellipse">
@@ -10125,7 +10125,7 @@
         </p:blipFill>
         <p:spPr>
           <a:xfrm>
-            <a:off x="788670" y="5625846"/>
+            <a:off x="788670" y="5465826"/>
             <a:ext cx="297180" cy="297180"/>
           </a:xfrm>
           <a:prstGeom prst="rect">
@@ -10141,7 +10141,7 @@
         </p:nvSpPr>
         <p:spPr>
           <a:xfrm>
-            <a:off x="1417320" y="5198364"/>
+            <a:off x="1417320" y="5038344"/>
             <a:ext cx="4358488" cy="1152144"/>
           </a:xfrm>
           <a:prstGeom prst="rect">
@@ -10178,11 +10178,11 @@
         <p:spPr>
           <a:xfrm>
             <a:off x="6233008" y="1417320"/>
-            <a:ext cx="5501488" cy="1395984"/>
+            <a:ext cx="5501488" cy="1610360"/>
           </a:xfrm>
           <a:prstGeom prst="roundRect">
             <a:avLst>
-              <a:gd name="adj" fmla="val 7860"/>
+              <a:gd name="adj" fmla="val 6814"/>
             </a:avLst>
           </a:prstGeom>
           <a:solidFill>
@@ -10199,7 +10199,7 @@
         </p:nvSpPr>
         <p:spPr>
           <a:xfrm>
-            <a:off x="6415888" y="1818132"/>
+            <a:off x="6415888" y="1925320"/>
             <a:ext cx="594360" cy="594360"/>
           </a:xfrm>
           <a:prstGeom prst="ellipse">
@@ -10227,7 +10227,7 @@
         </p:blipFill>
         <p:spPr>
           <a:xfrm>
-            <a:off x="6564478" y="1966722"/>
+            <a:off x="6564478" y="2073910"/>
             <a:ext cx="297180" cy="297180"/>
           </a:xfrm>
           <a:prstGeom prst="rect">
@@ -10244,7 +10244,7 @@
         <p:spPr>
           <a:xfrm>
             <a:off x="7193128" y="1417320"/>
-            <a:ext cx="4358488" cy="1395984"/>
+            <a:ext cx="4358488" cy="1610360"/>
           </a:xfrm>
           <a:prstGeom prst="rect">
             <a:avLst/>
@@ -10279,12 +10279,12 @@
         </p:nvSpPr>
         <p:spPr>
           <a:xfrm>
-            <a:off x="6233008" y="2996184"/>
-            <a:ext cx="5501488" cy="1152144"/>
+            <a:off x="6233008" y="3210560"/>
+            <a:ext cx="5501488" cy="1366520"/>
           </a:xfrm>
           <a:prstGeom prst="roundRect">
             <a:avLst>
-              <a:gd name="adj" fmla="val 9524"/>
+              <a:gd name="adj" fmla="val 8030"/>
             </a:avLst>
           </a:prstGeom>
           <a:solidFill>
@@ -10301,7 +10301,7 @@
         </p:nvSpPr>
         <p:spPr>
           <a:xfrm>
-            <a:off x="6415888" y="3275076"/>
+            <a:off x="6415888" y="3596640"/>
             <a:ext cx="594360" cy="594360"/>
           </a:xfrm>
           <a:prstGeom prst="ellipse">
@@ -10329,7 +10329,7 @@
         </p:blipFill>
         <p:spPr>
           <a:xfrm>
-            <a:off x="6564478" y="3423666"/>
+            <a:off x="6564478" y="3745230"/>
             <a:ext cx="297180" cy="297180"/>
           </a:xfrm>
           <a:prstGeom prst="rect">
@@ -10345,8 +10345,8 @@
         </p:nvSpPr>
         <p:spPr>
           <a:xfrm>
-            <a:off x="7193128" y="2996184"/>
-            <a:ext cx="4358488" cy="1152144"/>
+            <a:off x="7193128" y="3210560"/>
+            <a:ext cx="4358488" cy="1366520"/>
           </a:xfrm>
           <a:prstGeom prst="rect">
             <a:avLst/>
@@ -10381,12 +10381,12 @@
         </p:nvSpPr>
         <p:spPr>
           <a:xfrm>
-            <a:off x="6233008" y="4331208"/>
-            <a:ext cx="5501488" cy="1152144"/>
+            <a:off x="6233008" y="4759960"/>
+            <a:ext cx="5501488" cy="1366520"/>
           </a:xfrm>
           <a:prstGeom prst="roundRect">
             <a:avLst>
-              <a:gd name="adj" fmla="val 9524"/>
+              <a:gd name="adj" fmla="val 8030"/>
             </a:avLst>
           </a:prstGeom>
           <a:solidFill>
@@ -10403,7 +10403,7 @@
         </p:nvSpPr>
         <p:spPr>
           <a:xfrm>
-            <a:off x="6415888" y="4610100"/>
+            <a:off x="6415888" y="5146040"/>
             <a:ext cx="594360" cy="594360"/>
           </a:xfrm>
           <a:prstGeom prst="ellipse">
@@ -10431,7 +10431,7 @@
         </p:blipFill>
         <p:spPr>
           <a:xfrm>
-            <a:off x="6564478" y="4758690"/>
+            <a:off x="6564478" y="5294630"/>
             <a:ext cx="297180" cy="297180"/>
           </a:xfrm>
           <a:prstGeom prst="rect">
@@ -10447,8 +10447,8 @@
         </p:nvSpPr>
         <p:spPr>
           <a:xfrm>
-            <a:off x="7193128" y="4331208"/>
-            <a:ext cx="4358488" cy="1152144"/>
+            <a:off x="7193128" y="4759960"/>
+            <a:ext cx="4358488" cy="1366520"/>
           </a:xfrm>
           <a:prstGeom prst="rect">
             <a:avLst/>
@@ -12831,8 +12831,8 @@
         </p:nvSpPr>
         <p:spPr>
           <a:xfrm>
-            <a:off x="685800" y="2240280"/>
-            <a:ext cx="1950644" cy="320040"/>
+            <a:off x="1371600" y="1645920"/>
+            <a:ext cx="1264844" cy="502920"/>
           </a:xfrm>
           <a:prstGeom prst="rect">
             <a:avLst/>
@@ -12841,21 +12841,21 @@
           <a:ln/>
         </p:spPr>
         <p:txBody>
-          <a:bodyPr wrap="square" lIns="0" tIns="0" rIns="0" bIns="0" rtlCol="0" anchor="t"/>
+          <a:bodyPr wrap="square" lIns="0" tIns="0" rIns="0" bIns="0" rtlCol="0" anchor="ctr"/>
           <a:lstStyle/>
           <a:p>
             <a:pPr algn="l" indent="0" marL="0">
               <a:buNone/>
             </a:pPr>
             <a:r>
-              <a:rPr lang="en-US" sz="1800" b="1" dirty="0">
+              <a:rPr lang="en-US" sz="1600" b="1" dirty="0">
                 <a:solidFill>
                   <a:schemeClr val="tx2"/>
                 </a:solidFill>
               </a:rPr>
               <a:t>Prepare</a:t>
             </a:r>
-            <a:endParaRPr lang="en-US" sz="1800" dirty="0"/>
+            <a:endParaRPr lang="en-US" sz="1600" dirty="0"/>
           </a:p>
         </p:txBody>
       </p:sp>
@@ -12867,8 +12867,8 @@
         </p:nvSpPr>
         <p:spPr>
           <a:xfrm>
-            <a:off x="685800" y="2560320"/>
-            <a:ext cx="1950644" cy="754380"/>
+            <a:off x="685800" y="2240280"/>
+            <a:ext cx="1950644" cy="1074420"/>
           </a:xfrm>
           <a:prstGeom prst="rect">
             <a:avLst/>
@@ -12983,8 +12983,8 @@
         </p:nvSpPr>
         <p:spPr>
           <a:xfrm>
-            <a:off x="3642284" y="2240280"/>
-            <a:ext cx="1950644" cy="320040"/>
+            <a:off x="4328084" y="1645920"/>
+            <a:ext cx="1264844" cy="502920"/>
           </a:xfrm>
           <a:prstGeom prst="rect">
             <a:avLst/>
@@ -12993,21 +12993,21 @@
           <a:ln/>
         </p:spPr>
         <p:txBody>
-          <a:bodyPr wrap="square" lIns="0" tIns="0" rIns="0" bIns="0" rtlCol="0" anchor="t"/>
+          <a:bodyPr wrap="square" lIns="0" tIns="0" rIns="0" bIns="0" rtlCol="0" anchor="ctr"/>
           <a:lstStyle/>
           <a:p>
             <a:pPr algn="l" indent="0" marL="0">
               <a:buNone/>
             </a:pPr>
             <a:r>
-              <a:rPr lang="en-US" sz="1800" b="1" dirty="0">
+              <a:rPr lang="en-US" sz="1600" b="1" dirty="0">
                 <a:solidFill>
                   <a:schemeClr val="tx2"/>
                 </a:solidFill>
               </a:rPr>
               <a:t>Register</a:t>
             </a:r>
-            <a:endParaRPr lang="en-US" sz="1800" dirty="0"/>
+            <a:endParaRPr lang="en-US" sz="1600" dirty="0"/>
           </a:p>
         </p:txBody>
       </p:sp>
@@ -13019,8 +13019,8 @@
         </p:nvSpPr>
         <p:spPr>
           <a:xfrm>
-            <a:off x="3642284" y="2560320"/>
-            <a:ext cx="1950644" cy="754380"/>
+            <a:off x="3642284" y="2240280"/>
+            <a:ext cx="1950644" cy="1074420"/>
           </a:xfrm>
           <a:prstGeom prst="rect">
             <a:avLst/>
@@ -13135,8 +13135,8 @@
         </p:nvSpPr>
         <p:spPr>
           <a:xfrm>
-            <a:off x="6598768" y="2240280"/>
-            <a:ext cx="1950644" cy="320040"/>
+            <a:off x="7284568" y="1645920"/>
+            <a:ext cx="1264844" cy="502920"/>
           </a:xfrm>
           <a:prstGeom prst="rect">
             <a:avLst/>
@@ -13145,21 +13145,21 @@
           <a:ln/>
         </p:spPr>
         <p:txBody>
-          <a:bodyPr wrap="square" lIns="0" tIns="0" rIns="0" bIns="0" rtlCol="0" anchor="t"/>
+          <a:bodyPr wrap="square" lIns="0" tIns="0" rIns="0" bIns="0" rtlCol="0" anchor="ctr"/>
           <a:lstStyle/>
           <a:p>
             <a:pPr algn="l" indent="0" marL="0">
               <a:buNone/>
             </a:pPr>
             <a:r>
-              <a:rPr lang="en-US" sz="1800" b="1" dirty="0">
+              <a:rPr lang="en-US" sz="1600" b="1" dirty="0">
                 <a:solidFill>
                   <a:schemeClr val="tx2"/>
                 </a:solidFill>
               </a:rPr>
               <a:t>Plan</a:t>
             </a:r>
-            <a:endParaRPr lang="en-US" sz="1800" dirty="0"/>
+            <a:endParaRPr lang="en-US" sz="1600" dirty="0"/>
           </a:p>
         </p:txBody>
       </p:sp>
@@ -13171,8 +13171,8 @@
         </p:nvSpPr>
         <p:spPr>
           <a:xfrm>
-            <a:off x="6598768" y="2560320"/>
-            <a:ext cx="1950644" cy="754380"/>
+            <a:off x="6598768" y="2240280"/>
+            <a:ext cx="1950644" cy="1074420"/>
           </a:xfrm>
           <a:prstGeom prst="rect">
             <a:avLst/>
@@ -13287,8 +13287,8 @@
         </p:nvSpPr>
         <p:spPr>
           <a:xfrm>
-            <a:off x="9555251" y="2240280"/>
-            <a:ext cx="1950644" cy="320040"/>
+            <a:off x="10241051" y="1645920"/>
+            <a:ext cx="1264844" cy="502920"/>
           </a:xfrm>
           <a:prstGeom prst="rect">
             <a:avLst/>
@@ -13297,21 +13297,21 @@
           <a:ln/>
         </p:spPr>
         <p:txBody>
-          <a:bodyPr wrap="square" lIns="0" tIns="0" rIns="0" bIns="0" rtlCol="0" anchor="t"/>
+          <a:bodyPr wrap="square" lIns="0" tIns="0" rIns="0" bIns="0" rtlCol="0" anchor="ctr"/>
           <a:lstStyle/>
           <a:p>
             <a:pPr algn="l" indent="0" marL="0">
               <a:buNone/>
             </a:pPr>
             <a:r>
-              <a:rPr lang="en-US" sz="1800" b="1" dirty="0">
+              <a:rPr lang="en-US" sz="1600" b="1" dirty="0">
                 <a:solidFill>
                   <a:schemeClr val="tx2"/>
                 </a:solidFill>
               </a:rPr>
               <a:t>Series A and B</a:t>
             </a:r>
-            <a:endParaRPr lang="en-US" sz="1800" dirty="0"/>
+            <a:endParaRPr lang="en-US" sz="1600" dirty="0"/>
           </a:p>
         </p:txBody>
       </p:sp>
@@ -13323,8 +13323,8 @@
         </p:nvSpPr>
         <p:spPr>
           <a:xfrm>
-            <a:off x="9555251" y="2560320"/>
-            <a:ext cx="1950644" cy="754380"/>
+            <a:off x="9555251" y="2240280"/>
+            <a:ext cx="1950644" cy="1074420"/>
           </a:xfrm>
           <a:prstGeom prst="rect">
             <a:avLst/>
@@ -13419,8 +13419,8 @@
         </p:nvSpPr>
         <p:spPr>
           <a:xfrm>
-            <a:off x="685800" y="4823460"/>
-            <a:ext cx="1950644" cy="320040"/>
+            <a:off x="1371600" y="4229100"/>
+            <a:ext cx="1264844" cy="502920"/>
           </a:xfrm>
           <a:prstGeom prst="rect">
             <a:avLst/>
@@ -13429,21 +13429,21 @@
           <a:ln/>
         </p:spPr>
         <p:txBody>
-          <a:bodyPr wrap="square" lIns="0" tIns="0" rIns="0" bIns="0" rtlCol="0" anchor="t"/>
+          <a:bodyPr wrap="square" lIns="0" tIns="0" rIns="0" bIns="0" rtlCol="0" anchor="ctr"/>
           <a:lstStyle/>
           <a:p>
             <a:pPr algn="l" indent="0" marL="0">
               <a:buNone/>
             </a:pPr>
             <a:r>
-              <a:rPr lang="en-US" sz="1800" b="1" dirty="0">
+              <a:rPr lang="en-US" sz="1600" b="1" dirty="0">
                 <a:solidFill>
                   <a:schemeClr val="tx2"/>
                 </a:solidFill>
               </a:rPr>
               <a:t>Series Z</a:t>
             </a:r>
-            <a:endParaRPr lang="en-US" sz="1800" dirty="0"/>
+            <a:endParaRPr lang="en-US" sz="1600" dirty="0"/>
           </a:p>
         </p:txBody>
       </p:sp>
@@ -13455,8 +13455,8 @@
         </p:nvSpPr>
         <p:spPr>
           <a:xfrm>
-            <a:off x="685800" y="5143500"/>
-            <a:ext cx="1950644" cy="754380"/>
+            <a:off x="685800" y="4823460"/>
+            <a:ext cx="1950644" cy="1074420"/>
           </a:xfrm>
           <a:prstGeom prst="rect">
             <a:avLst/>
@@ -13571,8 +13571,8 @@
         </p:nvSpPr>
         <p:spPr>
           <a:xfrm>
-            <a:off x="3642284" y="4823460"/>
-            <a:ext cx="1950644" cy="320040"/>
+            <a:off x="4328084" y="4229100"/>
+            <a:ext cx="1264844" cy="502920"/>
           </a:xfrm>
           <a:prstGeom prst="rect">
             <a:avLst/>
@@ -13581,21 +13581,21 @@
           <a:ln/>
         </p:spPr>
         <p:txBody>
-          <a:bodyPr wrap="square" lIns="0" tIns="0" rIns="0" bIns="0" rtlCol="0" anchor="t"/>
+          <a:bodyPr wrap="square" lIns="0" tIns="0" rIns="0" bIns="0" rtlCol="0" anchor="ctr"/>
           <a:lstStyle/>
           <a:p>
             <a:pPr algn="l" indent="0" marL="0">
               <a:buNone/>
             </a:pPr>
             <a:r>
-              <a:rPr lang="en-US" sz="1800" b="1" dirty="0">
+              <a:rPr lang="en-US" sz="1600" b="1" dirty="0">
                 <a:solidFill>
                   <a:schemeClr val="tx2"/>
                 </a:solidFill>
               </a:rPr>
               <a:t>Series C and D</a:t>
             </a:r>
-            <a:endParaRPr lang="en-US" sz="1800" dirty="0"/>
+            <a:endParaRPr lang="en-US" sz="1600" dirty="0"/>
           </a:p>
         </p:txBody>
       </p:sp>
@@ -13607,8 +13607,8 @@
         </p:nvSpPr>
         <p:spPr>
           <a:xfrm>
-            <a:off x="3642284" y="5143500"/>
-            <a:ext cx="1950644" cy="754380"/>
+            <a:off x="3642284" y="4823460"/>
+            <a:ext cx="1950644" cy="1074420"/>
           </a:xfrm>
           <a:prstGeom prst="rect">
             <a:avLst/>
@@ -13723,8 +13723,8 @@
         </p:nvSpPr>
         <p:spPr>
           <a:xfrm>
-            <a:off x="6598768" y="4823460"/>
-            <a:ext cx="1950644" cy="320040"/>
+            <a:off x="7284568" y="4229100"/>
+            <a:ext cx="1264844" cy="502920"/>
           </a:xfrm>
           <a:prstGeom prst="rect">
             <a:avLst/>
@@ -13733,21 +13733,21 @@
           <a:ln/>
         </p:spPr>
         <p:txBody>
-          <a:bodyPr wrap="square" lIns="0" tIns="0" rIns="0" bIns="0" rtlCol="0" anchor="t"/>
+          <a:bodyPr wrap="square" lIns="0" tIns="0" rIns="0" bIns="0" rtlCol="0" anchor="ctr"/>
           <a:lstStyle/>
           <a:p>
             <a:pPr algn="l" indent="0" marL="0">
               <a:buNone/>
             </a:pPr>
             <a:r>
-              <a:rPr lang="en-US" sz="1800" b="1" dirty="0">
+              <a:rPr lang="en-US" sz="1600" b="1" dirty="0">
                 <a:solidFill>
                   <a:schemeClr val="tx2"/>
                 </a:solidFill>
               </a:rPr>
               <a:t>Hand over</a:t>
             </a:r>
-            <a:endParaRPr lang="en-US" sz="1800" dirty="0"/>
+            <a:endParaRPr lang="en-US" sz="1600" dirty="0"/>
           </a:p>
         </p:txBody>
       </p:sp>
@@ -13759,8 +13759,8 @@
         </p:nvSpPr>
         <p:spPr>
           <a:xfrm>
-            <a:off x="6598768" y="5143500"/>
-            <a:ext cx="1950644" cy="754380"/>
+            <a:off x="6598768" y="4823460"/>
+            <a:ext cx="1950644" cy="1074420"/>
           </a:xfrm>
           <a:prstGeom prst="rect">
             <a:avLst/>
@@ -15368,11 +15368,11 @@
         <p:spPr>
           <a:xfrm>
             <a:off x="457200" y="1417320"/>
-            <a:ext cx="5501488" cy="1943100"/>
+            <a:ext cx="5501488" cy="1868424"/>
           </a:xfrm>
           <a:prstGeom prst="roundRect">
             <a:avLst>
-              <a:gd name="adj" fmla="val 5647"/>
+              <a:gd name="adj" fmla="val 5873"/>
             </a:avLst>
           </a:prstGeom>
           <a:solidFill>
@@ -15401,14 +15401,14 @@
             <a:avLst/>
           </a:prstGeom>
           <a:solidFill>
-            <a:schemeClr val="accent4"/>
+            <a:schemeClr val="accent2"/>
           </a:solidFill>
           <a:ln/>
         </p:spPr>
       </p:sp>
       <p:pic>
         <p:nvPicPr>
-          <p:cNvPr id="5" name="Check 1 icon glyph" descr="warning icon">    </p:cNvPr>
+          <p:cNvPr id="5" name="Check 1 icon glyph" descr="sliders icon">    </p:cNvPr>
           <p:cNvPicPr>
             <a:picLocks noChangeAspect="1"/>
           </p:cNvPicPr>
@@ -15439,7 +15439,7 @@
         <p:spPr>
           <a:xfrm>
             <a:off x="1463040" y="1600200"/>
-            <a:ext cx="4312768" cy="1577340"/>
+            <a:ext cx="4312768" cy="1502664"/>
           </a:xfrm>
           <a:prstGeom prst="rect">
             <a:avLst/>
@@ -15509,11 +15509,11 @@
         <p:spPr>
           <a:xfrm>
             <a:off x="6233008" y="1417320"/>
-            <a:ext cx="5501488" cy="1943100"/>
+            <a:ext cx="5501488" cy="1868424"/>
           </a:xfrm>
           <a:prstGeom prst="roundRect">
             <a:avLst>
-              <a:gd name="adj" fmla="val 5647"/>
+              <a:gd name="adj" fmla="val 5873"/>
             </a:avLst>
           </a:prstGeom>
           <a:solidFill>
@@ -15542,14 +15542,14 @@
             <a:avLst/>
           </a:prstGeom>
           <a:solidFill>
-            <a:schemeClr val="accent4"/>
+            <a:schemeClr val="accent2"/>
           </a:solidFill>
           <a:ln/>
         </p:spPr>
       </p:sp>
       <p:pic>
         <p:nvPicPr>
-          <p:cNvPr id="9" name="Check 2 icon glyph" descr="warning icon">    </p:cNvPr>
+          <p:cNvPr id="9" name="Check 2 icon glyph" descr="clock icon">    </p:cNvPr>
           <p:cNvPicPr>
             <a:picLocks noChangeAspect="1"/>
           </p:cNvPicPr>
@@ -15580,7 +15580,7 @@
         <p:spPr>
           <a:xfrm>
             <a:off x="7238848" y="1600200"/>
-            <a:ext cx="4312768" cy="1577340"/>
+            <a:ext cx="4312768" cy="1502664"/>
           </a:xfrm>
           <a:prstGeom prst="rect">
             <a:avLst/>
@@ -15649,12 +15649,12 @@
         </p:nvSpPr>
         <p:spPr>
           <a:xfrm>
-            <a:off x="457200" y="3634740"/>
-            <a:ext cx="5501488" cy="1943100"/>
+            <a:off x="457200" y="3560064"/>
+            <a:ext cx="5501488" cy="2142744"/>
           </a:xfrm>
           <a:prstGeom prst="roundRect">
             <a:avLst>
-              <a:gd name="adj" fmla="val 5647"/>
+              <a:gd name="adj" fmla="val 5121"/>
             </a:avLst>
           </a:prstGeom>
           <a:solidFill>
@@ -15676,21 +15676,21 @@
         </p:nvSpPr>
         <p:spPr>
           <a:xfrm>
-            <a:off x="640080" y="3817620"/>
+            <a:off x="640080" y="3742944"/>
             <a:ext cx="640080" cy="640080"/>
           </a:xfrm>
           <a:prstGeom prst="ellipse">
             <a:avLst/>
           </a:prstGeom>
           <a:solidFill>
-            <a:schemeClr val="accent4"/>
+            <a:schemeClr val="accent2"/>
           </a:solidFill>
           <a:ln/>
         </p:spPr>
       </p:sp>
       <p:pic>
         <p:nvPicPr>
-          <p:cNvPr id="13" name="Check 3 icon glyph" descr="warning icon">    </p:cNvPr>
+          <p:cNvPr id="13" name="Check 3 icon glyph" descr="move icon">    </p:cNvPr>
           <p:cNvPicPr>
             <a:picLocks noChangeAspect="1"/>
           </p:cNvPicPr>
@@ -15704,7 +15704,7 @@
         </p:blipFill>
         <p:spPr>
           <a:xfrm>
-            <a:off x="800100" y="3977640"/>
+            <a:off x="800100" y="3902964"/>
             <a:ext cx="320040" cy="320040"/>
           </a:xfrm>
           <a:prstGeom prst="rect">
@@ -15720,8 +15720,8 @@
         </p:nvSpPr>
         <p:spPr>
           <a:xfrm>
-            <a:off x="1463040" y="3817620"/>
-            <a:ext cx="4312768" cy="1577340"/>
+            <a:off x="1463040" y="3742944"/>
+            <a:ext cx="4312768" cy="1776984"/>
           </a:xfrm>
           <a:prstGeom prst="rect">
             <a:avLst/>
@@ -15790,12 +15790,12 @@
         </p:nvSpPr>
         <p:spPr>
           <a:xfrm>
-            <a:off x="6233008" y="3634740"/>
-            <a:ext cx="5501488" cy="1943100"/>
+            <a:off x="6233008" y="3560064"/>
+            <a:ext cx="5501488" cy="2142744"/>
           </a:xfrm>
           <a:prstGeom prst="roundRect">
             <a:avLst>
-              <a:gd name="adj" fmla="val 5647"/>
+              <a:gd name="adj" fmla="val 5121"/>
             </a:avLst>
           </a:prstGeom>
           <a:solidFill>
@@ -15817,21 +15817,21 @@
         </p:nvSpPr>
         <p:spPr>
           <a:xfrm>
-            <a:off x="6415888" y="3817620"/>
+            <a:off x="6415888" y="3742944"/>
             <a:ext cx="640080" cy="640080"/>
           </a:xfrm>
           <a:prstGeom prst="ellipse">
             <a:avLst/>
           </a:prstGeom>
           <a:solidFill>
-            <a:schemeClr val="accent4"/>
+            <a:schemeClr val="accent2"/>
           </a:solidFill>
           <a:ln/>
         </p:spPr>
       </p:sp>
       <p:pic>
         <p:nvPicPr>
-          <p:cNvPr id="17" name="Check 4 icon glyph" descr="warning icon">    </p:cNvPr>
+          <p:cNvPr id="17" name="Check 4 icon glyph" descr="camera icon">    </p:cNvPr>
           <p:cNvPicPr>
             <a:picLocks noChangeAspect="1"/>
           </p:cNvPicPr>
@@ -15845,7 +15845,7 @@
         </p:blipFill>
         <p:spPr>
           <a:xfrm>
-            <a:off x="6575908" y="3977640"/>
+            <a:off x="6575908" y="3902964"/>
             <a:ext cx="320040" cy="320040"/>
           </a:xfrm>
           <a:prstGeom prst="rect">
@@ -15861,8 +15861,8 @@
         </p:nvSpPr>
         <p:spPr>
           <a:xfrm>
-            <a:off x="7238848" y="3817620"/>
-            <a:ext cx="4312768" cy="1577340"/>
+            <a:off x="7238848" y="3742944"/>
+            <a:ext cx="4312768" cy="1776984"/>
           </a:xfrm>
           <a:prstGeom prst="rect">
             <a:avLst/>
@@ -15931,8 +15931,8 @@
         </p:nvSpPr>
         <p:spPr>
           <a:xfrm>
-            <a:off x="457200" y="5852160"/>
-            <a:ext cx="11277295" cy="274320"/>
+            <a:off x="457200" y="5669280"/>
+            <a:ext cx="11277295" cy="457200"/>
           </a:xfrm>
           <a:prstGeom prst="rect">
             <a:avLst/>

</xml_diff>

<commit_message>
WIP: deck generator, assets and checks in progress (agent snapshot; superseded by the next commit)
Co-Authored-By: Claude Fable 5.1 <noreply@anthropic.com>
Claude-Session: https://claude.ai/code/session_01ERsPi9xhFu3U1nLCkBXPjN
</commit_message>
<xml_diff>
--- a/docs/presentations/vsx3000_test_procedure.pptx
+++ b/docs/presentations/vsx3000_test_procedure.pptx
@@ -126,7 +126,7 @@
   <p:extLst>
     <p:ext uri="{521415D9-36F7-43E2-AB2F-B90AF26B5E84}">
       <p14:sectionLst xmlns:p14="http://schemas.microsoft.com/office/powerpoint/2010/main">
-        <p14:section name="Introduction" id="{b47bdf1e-3234-2fc1-4060-1f73d612e30f}">
+        <p14:section name="Introduction" id="{3b354e0a-7989-4801-9cd3-def413595b05}">
           <p14:sldIdLst>
             <p14:sldId id="256"/>
             <p14:sldId id="257"/>
@@ -135,7 +135,7 @@
             <p14:sldId id="260"/>
           </p14:sldIdLst>
         </p14:section>
-        <p14:section name="Setup" id="{a1259c43-a2d4-3fce-bdeb-4ac74c8d490e}">
+        <p14:section name="Setup" id="{ee880393-b860-f94a-28c3-e118731315f5}">
           <p14:sldIdLst>
             <p14:sldId id="261"/>
             <p14:sldId id="262"/>
@@ -143,7 +143,7 @@
             <p14:sldId id="264"/>
           </p14:sldIdLst>
         </p14:section>
-        <p14:section name="Capture" id="{088ff3ff-8720-6c12-b38d-71f1584abf5d}">
+        <p14:section name="Capture" id="{50305cac-f6a5-9fff-61f0-11df207f671a}">
           <p14:sldIdLst>
             <p14:sldId id="265"/>
             <p14:sldId id="266"/>
@@ -155,12 +155,12 @@
             <p14:sldId id="272"/>
           </p14:sldIdLst>
         </p14:section>
-        <p14:section name="Checks" id="{68e082f9-5972-308a-5235-31ff36fcf61c}">
+        <p14:section name="Checks" id="{7e81be1c-866d-d82a-d46d-12fe25f2d19a}">
           <p14:sldIdLst>
             <p14:sldId id="273"/>
           </p14:sldIdLst>
         </p14:section>
-        <p14:section name="Wrap-up" id="{1947572c-7964-0bb5-c25b-58ac8acfe25a}">
+        <p14:section name="Wrap-up" id="{f341a2df-2708-aaa4-a7d0-ec3b9e075216}">
           <p14:sldIdLst>
             <p14:sldId id="274"/>
             <p14:sldId id="275"/>
@@ -2991,7 +2991,7 @@
               <a:buNone/>
             </a:pPr>
             <a:r>
-              <a:rPr lang="en-US" sz="4400" b="1" dirty="0">
+              <a:rPr lang="en-US" sz="3000" b="1" dirty="0">
                 <a:solidFill>
                   <a:schemeClr val="bg1"/>
                 </a:solidFill>
@@ -4385,7 +4385,7 @@
         <p:spPr>
           <a:xfrm>
             <a:off x="457200" y="1417320"/>
-            <a:ext cx="3576218" cy="3703320"/>
+            <a:ext cx="3576218" cy="3794760"/>
           </a:xfrm>
           <a:prstGeom prst="roundRect">
             <a:avLst>
@@ -4406,8 +4406,8 @@
         </p:nvSpPr>
         <p:spPr>
           <a:xfrm>
-            <a:off x="685800" y="1645920"/>
-            <a:ext cx="640080" cy="640080"/>
+            <a:off x="685800" y="1668780"/>
+            <a:ext cx="502920" cy="502920"/>
           </a:xfrm>
           <a:prstGeom prst="ellipse">
             <a:avLst/>
@@ -4434,8 +4434,8 @@
         </p:blipFill>
         <p:spPr>
           <a:xfrm>
-            <a:off x="845820" y="1805940"/>
-            <a:ext cx="320040" cy="320040"/>
+            <a:off x="811530" y="1794510"/>
+            <a:ext cx="251460" cy="251460"/>
           </a:xfrm>
           <a:prstGeom prst="rect">
             <a:avLst/>
@@ -4450,8 +4450,8 @@
         </p:nvSpPr>
         <p:spPr>
           <a:xfrm>
-            <a:off x="1508760" y="1645920"/>
-            <a:ext cx="2296058" cy="640080"/>
+            <a:off x="1371600" y="1645920"/>
+            <a:ext cx="2433218" cy="548640"/>
           </a:xfrm>
           <a:prstGeom prst="rect">
             <a:avLst/>
@@ -4467,7 +4467,7 @@
               <a:buNone/>
             </a:pPr>
             <a:r>
-              <a:rPr lang="en-US" sz="2000" b="1" dirty="0">
+              <a:rPr lang="en-US" sz="1800" b="1" dirty="0">
                 <a:solidFill>
                   <a:schemeClr val="tx2"/>
                 </a:solidFill>
@@ -4477,7 +4477,7 @@
               </a:rPr>
               <a:t>Inputs</a:t>
             </a:r>
-            <a:endParaRPr lang="en-US" sz="2000" dirty="0"/>
+            <a:endParaRPr lang="en-US" sz="1800" dirty="0"/>
           </a:p>
         </p:txBody>
       </p:sp>
@@ -4489,8 +4489,8 @@
         </p:nvSpPr>
         <p:spPr>
           <a:xfrm>
-            <a:off x="685800" y="2468880"/>
-            <a:ext cx="3119018" cy="2423160"/>
+            <a:off x="685800" y="2286000"/>
+            <a:ext cx="3119018" cy="2834640"/>
           </a:xfrm>
           <a:prstGeom prst="rect">
             <a:avLst/>
@@ -4504,7 +4504,7 @@
           <a:p>
             <a:pPr algn="l" marL="177800" indent="-177800">
               <a:spcAft>
-                <a:spcPts val="600"/>
+                <a:spcPts val="400"/>
               </a:spcAft>
               <a:buSzPct val="100000"/>
               <a:buChar char="•"/>
@@ -4522,7 +4522,7 @@
           <a:p>
             <a:pPr algn="l" marL="177800" indent="-177800">
               <a:spcAft>
-                <a:spcPts val="600"/>
+                <a:spcPts val="400"/>
               </a:spcAft>
               <a:buSzPct val="100000"/>
               <a:buChar char="•"/>
@@ -4548,7 +4548,7 @@
         <p:spPr>
           <a:xfrm>
             <a:off x="4307738" y="1417320"/>
-            <a:ext cx="3576218" cy="3703320"/>
+            <a:ext cx="3576218" cy="3794760"/>
           </a:xfrm>
           <a:prstGeom prst="roundRect">
             <a:avLst>
@@ -4569,8 +4569,8 @@
         </p:nvSpPr>
         <p:spPr>
           <a:xfrm>
-            <a:off x="4536338" y="1645920"/>
-            <a:ext cx="640080" cy="640080"/>
+            <a:off x="4536338" y="1668780"/>
+            <a:ext cx="502920" cy="502920"/>
           </a:xfrm>
           <a:prstGeom prst="ellipse">
             <a:avLst/>
@@ -4597,8 +4597,8 @@
         </p:blipFill>
         <p:spPr>
           <a:xfrm>
-            <a:off x="4696358" y="1805940"/>
-            <a:ext cx="320040" cy="320040"/>
+            <a:off x="4662068" y="1794510"/>
+            <a:ext cx="251460" cy="251460"/>
           </a:xfrm>
           <a:prstGeom prst="rect">
             <a:avLst/>
@@ -4613,8 +4613,8 @@
         </p:nvSpPr>
         <p:spPr>
           <a:xfrm>
-            <a:off x="5359298" y="1645920"/>
-            <a:ext cx="2296058" cy="640080"/>
+            <a:off x="5222138" y="1645920"/>
+            <a:ext cx="2433218" cy="548640"/>
           </a:xfrm>
           <a:prstGeom prst="rect">
             <a:avLst/>
@@ -4630,7 +4630,7 @@
               <a:buNone/>
             </a:pPr>
             <a:r>
-              <a:rPr lang="en-US" sz="2000" b="1" dirty="0">
+              <a:rPr lang="en-US" sz="1800" b="1" dirty="0">
                 <a:solidFill>
                   <a:schemeClr val="tx2"/>
                 </a:solidFill>
@@ -4640,7 +4640,7 @@
               </a:rPr>
               <a:t>Behavior</a:t>
             </a:r>
-            <a:endParaRPr lang="en-US" sz="2000" dirty="0"/>
+            <a:endParaRPr lang="en-US" sz="1800" dirty="0"/>
           </a:p>
         </p:txBody>
       </p:sp>
@@ -4652,8 +4652,8 @@
         </p:nvSpPr>
         <p:spPr>
           <a:xfrm>
-            <a:off x="4536338" y="2468880"/>
-            <a:ext cx="3119018" cy="2423160"/>
+            <a:off x="4536338" y="2286000"/>
+            <a:ext cx="3119018" cy="2834640"/>
           </a:xfrm>
           <a:prstGeom prst="rect">
             <a:avLst/>
@@ -4667,7 +4667,7 @@
           <a:p>
             <a:pPr algn="l" marL="177800" indent="-177800">
               <a:spcAft>
-                <a:spcPts val="600"/>
+                <a:spcPts val="400"/>
               </a:spcAft>
               <a:buSzPct val="100000"/>
               <a:buChar char="•"/>
@@ -4685,7 +4685,7 @@
           <a:p>
             <a:pPr algn="l" marL="177800" indent="-177800">
               <a:spcAft>
-                <a:spcPts val="600"/>
+                <a:spcPts val="400"/>
               </a:spcAft>
               <a:buSzPct val="100000"/>
               <a:buChar char="•"/>
@@ -4703,7 +4703,7 @@
           <a:p>
             <a:pPr algn="l" marL="177800" indent="-177800">
               <a:spcAft>
-                <a:spcPts val="600"/>
+                <a:spcPts val="400"/>
               </a:spcAft>
               <a:buSzPct val="100000"/>
               <a:buChar char="•"/>
@@ -4729,7 +4729,7 @@
         <p:spPr>
           <a:xfrm>
             <a:off x="8158277" y="1417320"/>
-            <a:ext cx="3576218" cy="3703320"/>
+            <a:ext cx="3576218" cy="3794760"/>
           </a:xfrm>
           <a:prstGeom prst="roundRect">
             <a:avLst>
@@ -4750,8 +4750,8 @@
         </p:nvSpPr>
         <p:spPr>
           <a:xfrm>
-            <a:off x="8386877" y="1645920"/>
-            <a:ext cx="640080" cy="640080"/>
+            <a:off x="8386877" y="1668780"/>
+            <a:ext cx="502920" cy="502920"/>
           </a:xfrm>
           <a:prstGeom prst="ellipse">
             <a:avLst/>
@@ -4778,8 +4778,8 @@
         </p:blipFill>
         <p:spPr>
           <a:xfrm>
-            <a:off x="8546897" y="1805940"/>
-            <a:ext cx="320040" cy="320040"/>
+            <a:off x="8512607" y="1794510"/>
+            <a:ext cx="251460" cy="251460"/>
           </a:xfrm>
           <a:prstGeom prst="rect">
             <a:avLst/>
@@ -4794,8 +4794,8 @@
         </p:nvSpPr>
         <p:spPr>
           <a:xfrm>
-            <a:off x="9209837" y="1645920"/>
-            <a:ext cx="2296058" cy="640080"/>
+            <a:off x="9072677" y="1645920"/>
+            <a:ext cx="2433218" cy="548640"/>
           </a:xfrm>
           <a:prstGeom prst="rect">
             <a:avLst/>
@@ -4811,7 +4811,7 @@
               <a:buNone/>
             </a:pPr>
             <a:r>
-              <a:rPr lang="en-US" sz="2000" b="1" dirty="0">
+              <a:rPr lang="en-US" sz="1800" b="1" dirty="0">
                 <a:solidFill>
                   <a:schemeClr val="tx2"/>
                 </a:solidFill>
@@ -4821,7 +4821,7 @@
               </a:rPr>
               <a:t>Outputs</a:t>
             </a:r>
-            <a:endParaRPr lang="en-US" sz="2000" dirty="0"/>
+            <a:endParaRPr lang="en-US" sz="1800" dirty="0"/>
           </a:p>
         </p:txBody>
       </p:sp>
@@ -4833,8 +4833,8 @@
         </p:nvSpPr>
         <p:spPr>
           <a:xfrm>
-            <a:off x="8386877" y="2468880"/>
-            <a:ext cx="3119018" cy="2423160"/>
+            <a:off x="8386877" y="2286000"/>
+            <a:ext cx="3119018" cy="2834640"/>
           </a:xfrm>
           <a:prstGeom prst="rect">
             <a:avLst/>
@@ -4848,7 +4848,7 @@
           <a:p>
             <a:pPr algn="l" marL="177800" indent="-177800">
               <a:spcAft>
-                <a:spcPts val="600"/>
+                <a:spcPts val="400"/>
               </a:spcAft>
               <a:buSzPct val="100000"/>
               <a:buChar char="•"/>
@@ -4866,7 +4866,7 @@
           <a:p>
             <a:pPr algn="l" marL="177800" indent="-177800">
               <a:spcAft>
-                <a:spcPts val="600"/>
+                <a:spcPts val="400"/>
               </a:spcAft>
               <a:buSzPct val="100000"/>
               <a:buChar char="•"/>
@@ -5110,7 +5110,7 @@
         <p:spPr>
           <a:xfrm>
             <a:off x="457200" y="1417320"/>
-            <a:ext cx="2407844" cy="2926080"/>
+            <a:ext cx="2407844" cy="2834640"/>
           </a:xfrm>
           <a:prstGeom prst="roundRect">
             <a:avLst>
@@ -5169,8 +5169,8 @@
         </p:nvSpPr>
         <p:spPr>
           <a:xfrm>
-            <a:off x="685800" y="2240280"/>
-            <a:ext cx="1950644" cy="320040"/>
+            <a:off x="1371600" y="1645920"/>
+            <a:ext cx="1264844" cy="502920"/>
           </a:xfrm>
           <a:prstGeom prst="rect">
             <a:avLst/>
@@ -5179,21 +5179,21 @@
           <a:ln/>
         </p:spPr>
         <p:txBody>
-          <a:bodyPr wrap="square" lIns="0" tIns="0" rIns="0" bIns="0" rtlCol="0" anchor="t"/>
+          <a:bodyPr wrap="square" lIns="0" tIns="0" rIns="0" bIns="0" rtlCol="0" anchor="ctr"/>
           <a:lstStyle/>
           <a:p>
             <a:pPr algn="l" indent="0" marL="0">
               <a:buNone/>
             </a:pPr>
             <a:r>
-              <a:rPr lang="en-US" sz="1800" b="1" dirty="0">
+              <a:rPr lang="en-US" sz="1600" b="1" dirty="0">
                 <a:solidFill>
                   <a:schemeClr val="tx2"/>
                 </a:solidFill>
               </a:rPr>
               <a:t>Move</a:t>
             </a:r>
-            <a:endParaRPr lang="en-US" sz="1800" dirty="0"/>
+            <a:endParaRPr lang="en-US" sz="1600" dirty="0"/>
           </a:p>
         </p:txBody>
       </p:sp>
@@ -5205,8 +5205,8 @@
         </p:nvSpPr>
         <p:spPr>
           <a:xfrm>
-            <a:off x="685800" y="2560320"/>
-            <a:ext cx="1950644" cy="1554480"/>
+            <a:off x="685800" y="2240280"/>
+            <a:ext cx="1950644" cy="1783080"/>
           </a:xfrm>
           <a:prstGeom prst="rect">
             <a:avLst/>
@@ -5241,7 +5241,7 @@
         </p:nvSpPr>
         <p:spPr>
           <a:xfrm>
-            <a:off x="3025064" y="2697480"/>
+            <a:off x="3025064" y="2651760"/>
             <a:ext cx="228600" cy="365760"/>
           </a:xfrm>
           <a:prstGeom prst="chevron">
@@ -5262,7 +5262,7 @@
         <p:spPr>
           <a:xfrm>
             <a:off x="3413684" y="1417320"/>
-            <a:ext cx="2407844" cy="2926080"/>
+            <a:ext cx="2407844" cy="2834640"/>
           </a:xfrm>
           <a:prstGeom prst="roundRect">
             <a:avLst>
@@ -5321,8 +5321,8 @@
         </p:nvSpPr>
         <p:spPr>
           <a:xfrm>
-            <a:off x="3642284" y="2240280"/>
-            <a:ext cx="1950644" cy="320040"/>
+            <a:off x="4328084" y="1645920"/>
+            <a:ext cx="1264844" cy="502920"/>
           </a:xfrm>
           <a:prstGeom prst="rect">
             <a:avLst/>
@@ -5331,21 +5331,21 @@
           <a:ln/>
         </p:spPr>
         <p:txBody>
-          <a:bodyPr wrap="square" lIns="0" tIns="0" rIns="0" bIns="0" rtlCol="0" anchor="t"/>
+          <a:bodyPr wrap="square" lIns="0" tIns="0" rIns="0" bIns="0" rtlCol="0" anchor="ctr"/>
           <a:lstStyle/>
           <a:p>
             <a:pPr algn="l" indent="0" marL="0">
               <a:buNone/>
             </a:pPr>
             <a:r>
-              <a:rPr lang="en-US" sz="1800" b="1" dirty="0">
+              <a:rPr lang="en-US" sz="1600" b="1" dirty="0">
                 <a:solidFill>
                   <a:schemeClr val="tx2"/>
                 </a:solidFill>
               </a:rPr>
               <a:t>Settle</a:t>
             </a:r>
-            <a:endParaRPr lang="en-US" sz="1800" dirty="0"/>
+            <a:endParaRPr lang="en-US" sz="1600" dirty="0"/>
           </a:p>
         </p:txBody>
       </p:sp>
@@ -5357,8 +5357,8 @@
         </p:nvSpPr>
         <p:spPr>
           <a:xfrm>
-            <a:off x="3642284" y="2560320"/>
-            <a:ext cx="1950644" cy="1554480"/>
+            <a:off x="3642284" y="2240280"/>
+            <a:ext cx="1950644" cy="1783080"/>
           </a:xfrm>
           <a:prstGeom prst="rect">
             <a:avLst/>
@@ -5393,7 +5393,7 @@
         </p:nvSpPr>
         <p:spPr>
           <a:xfrm>
-            <a:off x="5981548" y="2697480"/>
+            <a:off x="5981548" y="2651760"/>
             <a:ext cx="228600" cy="365760"/>
           </a:xfrm>
           <a:prstGeom prst="chevron">
@@ -5414,7 +5414,7 @@
         <p:spPr>
           <a:xfrm>
             <a:off x="6370168" y="1417320"/>
-            <a:ext cx="2407844" cy="2926080"/>
+            <a:ext cx="2407844" cy="2834640"/>
           </a:xfrm>
           <a:prstGeom prst="roundRect">
             <a:avLst>
@@ -5473,8 +5473,8 @@
         </p:nvSpPr>
         <p:spPr>
           <a:xfrm>
-            <a:off x="6598768" y="2240280"/>
-            <a:ext cx="1950644" cy="320040"/>
+            <a:off x="7284568" y="1645920"/>
+            <a:ext cx="1264844" cy="502920"/>
           </a:xfrm>
           <a:prstGeom prst="rect">
             <a:avLst/>
@@ -5483,21 +5483,21 @@
           <a:ln/>
         </p:spPr>
         <p:txBody>
-          <a:bodyPr wrap="square" lIns="0" tIns="0" rIns="0" bIns="0" rtlCol="0" anchor="t"/>
+          <a:bodyPr wrap="square" lIns="0" tIns="0" rIns="0" bIns="0" rtlCol="0" anchor="ctr"/>
           <a:lstStyle/>
           <a:p>
             <a:pPr algn="l" indent="0" marL="0">
               <a:buNone/>
             </a:pPr>
             <a:r>
-              <a:rPr lang="en-US" sz="1800" b="1" dirty="0">
+              <a:rPr lang="en-US" sz="1600" b="1" dirty="0">
                 <a:solidFill>
                   <a:schemeClr val="tx2"/>
                 </a:solidFill>
               </a:rPr>
               <a:t>Capture</a:t>
             </a:r>
-            <a:endParaRPr lang="en-US" sz="1800" dirty="0"/>
+            <a:endParaRPr lang="en-US" sz="1600" dirty="0"/>
           </a:p>
         </p:txBody>
       </p:sp>
@@ -5509,8 +5509,8 @@
         </p:nvSpPr>
         <p:spPr>
           <a:xfrm>
-            <a:off x="6598768" y="2560320"/>
-            <a:ext cx="1950644" cy="1554480"/>
+            <a:off x="6598768" y="2240280"/>
+            <a:ext cx="1950644" cy="1783080"/>
           </a:xfrm>
           <a:prstGeom prst="rect">
             <a:avLst/>
@@ -5545,7 +5545,7 @@
         </p:nvSpPr>
         <p:spPr>
           <a:xfrm>
-            <a:off x="8938031" y="2697480"/>
+            <a:off x="8938031" y="2651760"/>
             <a:ext cx="228600" cy="365760"/>
           </a:xfrm>
           <a:prstGeom prst="chevron">
@@ -5566,7 +5566,7 @@
         <p:spPr>
           <a:xfrm>
             <a:off x="9326651" y="1417320"/>
-            <a:ext cx="2407844" cy="2926080"/>
+            <a:ext cx="2407844" cy="2834640"/>
           </a:xfrm>
           <a:prstGeom prst="roundRect">
             <a:avLst>
@@ -5625,8 +5625,8 @@
         </p:nvSpPr>
         <p:spPr>
           <a:xfrm>
-            <a:off x="9555251" y="2240280"/>
-            <a:ext cx="1950644" cy="320040"/>
+            <a:off x="10241051" y="1645920"/>
+            <a:ext cx="1264844" cy="502920"/>
           </a:xfrm>
           <a:prstGeom prst="rect">
             <a:avLst/>
@@ -5635,21 +5635,21 @@
           <a:ln/>
         </p:spPr>
         <p:txBody>
-          <a:bodyPr wrap="square" lIns="0" tIns="0" rIns="0" bIns="0" rtlCol="0" anchor="t"/>
+          <a:bodyPr wrap="square" lIns="0" tIns="0" rIns="0" bIns="0" rtlCol="0" anchor="ctr"/>
           <a:lstStyle/>
           <a:p>
             <a:pPr algn="l" indent="0" marL="0">
               <a:buNone/>
             </a:pPr>
             <a:r>
-              <a:rPr lang="en-US" sz="1800" b="1" dirty="0">
+              <a:rPr lang="en-US" sz="1600" b="1" dirty="0">
                 <a:solidFill>
                   <a:schemeClr val="tx2"/>
                 </a:solidFill>
               </a:rPr>
               <a:t>Log</a:t>
             </a:r>
-            <a:endParaRPr lang="en-US" sz="1800" dirty="0"/>
+            <a:endParaRPr lang="en-US" sz="1600" dirty="0"/>
           </a:p>
         </p:txBody>
       </p:sp>
@@ -5661,8 +5661,8 @@
         </p:nvSpPr>
         <p:spPr>
           <a:xfrm>
-            <a:off x="9555251" y="2560320"/>
-            <a:ext cx="1950644" cy="1554480"/>
+            <a:off x="9555251" y="2240280"/>
+            <a:ext cx="1950644" cy="1783080"/>
           </a:xfrm>
           <a:prstGeom prst="rect">
             <a:avLst/>
@@ -5697,12 +5697,12 @@
         </p:nvSpPr>
         <p:spPr>
           <a:xfrm>
-            <a:off x="457200" y="4617720"/>
-            <a:ext cx="2407844" cy="1508760"/>
+            <a:off x="457200" y="4526280"/>
+            <a:ext cx="2407844" cy="1600200"/>
           </a:xfrm>
           <a:prstGeom prst="roundRect">
             <a:avLst>
-              <a:gd name="adj" fmla="val 7273"/>
+              <a:gd name="adj" fmla="val 6857"/>
             </a:avLst>
           </a:prstGeom>
           <a:solidFill>
@@ -5719,7 +5719,7 @@
         </p:nvSpPr>
         <p:spPr>
           <a:xfrm>
-            <a:off x="685800" y="4823460"/>
+            <a:off x="685800" y="4617720"/>
             <a:ext cx="1950644" cy="548640"/>
           </a:xfrm>
           <a:prstGeom prst="rect">
@@ -5758,8 +5758,8 @@
         </p:nvSpPr>
         <p:spPr>
           <a:xfrm>
-            <a:off x="685800" y="5372100"/>
-            <a:ext cx="1950644" cy="548640"/>
+            <a:off x="685800" y="5166360"/>
+            <a:ext cx="1950644" cy="868680"/>
           </a:xfrm>
           <a:prstGeom prst="rect">
             <a:avLst/>
@@ -5794,12 +5794,12 @@
         </p:nvSpPr>
         <p:spPr>
           <a:xfrm>
-            <a:off x="3139364" y="4617720"/>
-            <a:ext cx="2407844" cy="1508760"/>
+            <a:off x="3139364" y="4526280"/>
+            <a:ext cx="2407844" cy="1600200"/>
           </a:xfrm>
           <a:prstGeom prst="roundRect">
             <a:avLst>
-              <a:gd name="adj" fmla="val 7273"/>
+              <a:gd name="adj" fmla="val 6857"/>
             </a:avLst>
           </a:prstGeom>
           <a:solidFill>
@@ -5816,7 +5816,7 @@
         </p:nvSpPr>
         <p:spPr>
           <a:xfrm>
-            <a:off x="3367964" y="4823460"/>
+            <a:off x="3367964" y="4617720"/>
             <a:ext cx="1950644" cy="548640"/>
           </a:xfrm>
           <a:prstGeom prst="rect">
@@ -5855,8 +5855,8 @@
         </p:nvSpPr>
         <p:spPr>
           <a:xfrm>
-            <a:off x="3367964" y="5372100"/>
-            <a:ext cx="1950644" cy="548640"/>
+            <a:off x="3367964" y="5166360"/>
+            <a:ext cx="1950644" cy="868680"/>
           </a:xfrm>
           <a:prstGeom prst="rect">
             <a:avLst/>
@@ -5891,12 +5891,12 @@
         </p:nvSpPr>
         <p:spPr>
           <a:xfrm>
-            <a:off x="5821528" y="4617720"/>
-            <a:ext cx="5912968" cy="1508760"/>
+            <a:off x="5821528" y="4526280"/>
+            <a:ext cx="5912968" cy="1600200"/>
           </a:xfrm>
           <a:prstGeom prst="roundRect">
             <a:avLst>
-              <a:gd name="adj" fmla="val 7273"/>
+              <a:gd name="adj" fmla="val 6857"/>
             </a:avLst>
           </a:prstGeom>
           <a:solidFill>
@@ -5918,7 +5918,7 @@
         </p:nvSpPr>
         <p:spPr>
           <a:xfrm>
-            <a:off x="6050128" y="5052060"/>
+            <a:off x="6050128" y="5006340"/>
             <a:ext cx="640080" cy="640080"/>
           </a:xfrm>
           <a:prstGeom prst="ellipse">
@@ -5946,7 +5946,7 @@
         </p:blipFill>
         <p:spPr>
           <a:xfrm>
-            <a:off x="6210148" y="5212080"/>
+            <a:off x="6210148" y="5166360"/>
             <a:ext cx="320040" cy="320040"/>
           </a:xfrm>
           <a:prstGeom prst="rect">
@@ -5962,8 +5962,8 @@
         </p:nvSpPr>
         <p:spPr>
           <a:xfrm>
-            <a:off x="6873088" y="4617720"/>
-            <a:ext cx="4632808" cy="1508760"/>
+            <a:off x="6873088" y="4526280"/>
+            <a:ext cx="4632808" cy="1600200"/>
           </a:xfrm>
           <a:prstGeom prst="rect">
             <a:avLst/>
@@ -6110,11 +6110,11 @@
         <p:spPr>
           <a:xfrm>
             <a:off x="457200" y="1417320"/>
-            <a:ext cx="5501488" cy="2295144"/>
+            <a:ext cx="5501488" cy="2247900"/>
           </a:xfrm>
           <a:prstGeom prst="roundRect">
             <a:avLst>
-              <a:gd name="adj" fmla="val 4781"/>
+              <a:gd name="adj" fmla="val 4881"/>
             </a:avLst>
           </a:prstGeom>
           <a:solidFill>
@@ -6136,7 +6136,7 @@
         </p:nvSpPr>
         <p:spPr>
           <a:xfrm>
-            <a:off x="640080" y="1600200"/>
+            <a:off x="594360" y="1554480"/>
             <a:ext cx="640080" cy="640080"/>
           </a:xfrm>
           <a:prstGeom prst="ellipse">
@@ -6164,7 +6164,7 @@
         </p:blipFill>
         <p:spPr>
           <a:xfrm>
-            <a:off x="800100" y="1760220"/>
+            <a:off x="754380" y="1714500"/>
             <a:ext cx="320040" cy="320040"/>
           </a:xfrm>
           <a:prstGeom prst="rect">
@@ -6180,8 +6180,8 @@
         </p:nvSpPr>
         <p:spPr>
           <a:xfrm>
-            <a:off x="1463040" y="1600200"/>
-            <a:ext cx="4312768" cy="1929384"/>
+            <a:off x="1417320" y="1554480"/>
+            <a:ext cx="4404208" cy="1973580"/>
           </a:xfrm>
           <a:prstGeom prst="rect">
             <a:avLst/>
@@ -6251,11 +6251,11 @@
         <p:spPr>
           <a:xfrm>
             <a:off x="6233008" y="1417320"/>
-            <a:ext cx="5501488" cy="2295144"/>
+            <a:ext cx="5501488" cy="2247900"/>
           </a:xfrm>
           <a:prstGeom prst="roundRect">
             <a:avLst>
-              <a:gd name="adj" fmla="val 4781"/>
+              <a:gd name="adj" fmla="val 4881"/>
             </a:avLst>
           </a:prstGeom>
           <a:solidFill>
@@ -6277,7 +6277,7 @@
         </p:nvSpPr>
         <p:spPr>
           <a:xfrm>
-            <a:off x="6415888" y="1600200"/>
+            <a:off x="6370168" y="1554480"/>
             <a:ext cx="640080" cy="640080"/>
           </a:xfrm>
           <a:prstGeom prst="ellipse">
@@ -6305,7 +6305,7 @@
         </p:blipFill>
         <p:spPr>
           <a:xfrm>
-            <a:off x="6575908" y="1760220"/>
+            <a:off x="6530188" y="1714500"/>
             <a:ext cx="320040" cy="320040"/>
           </a:xfrm>
           <a:prstGeom prst="rect">
@@ -6321,8 +6321,8 @@
         </p:nvSpPr>
         <p:spPr>
           <a:xfrm>
-            <a:off x="7238848" y="1600200"/>
-            <a:ext cx="4312768" cy="1929384"/>
+            <a:off x="7193128" y="1554480"/>
+            <a:ext cx="4404208" cy="1973580"/>
           </a:xfrm>
           <a:prstGeom prst="rect">
             <a:avLst/>
@@ -6391,12 +6391,12 @@
         </p:nvSpPr>
         <p:spPr>
           <a:xfrm>
-            <a:off x="457200" y="3986784"/>
-            <a:ext cx="5501488" cy="1868424"/>
+            <a:off x="457200" y="3848100"/>
+            <a:ext cx="5501488" cy="1821180"/>
           </a:xfrm>
           <a:prstGeom prst="roundRect">
             <a:avLst>
-              <a:gd name="adj" fmla="val 5873"/>
+              <a:gd name="adj" fmla="val 6025"/>
             </a:avLst>
           </a:prstGeom>
           <a:solidFill>
@@ -6418,7 +6418,7 @@
         </p:nvSpPr>
         <p:spPr>
           <a:xfrm>
-            <a:off x="640080" y="4169664"/>
+            <a:off x="594360" y="3985260"/>
             <a:ext cx="640080" cy="640080"/>
           </a:xfrm>
           <a:prstGeom prst="ellipse">
@@ -6446,7 +6446,7 @@
         </p:blipFill>
         <p:spPr>
           <a:xfrm>
-            <a:off x="800100" y="4329684"/>
+            <a:off x="754380" y="4145280"/>
             <a:ext cx="320040" cy="320040"/>
           </a:xfrm>
           <a:prstGeom prst="rect">
@@ -6462,8 +6462,8 @@
         </p:nvSpPr>
         <p:spPr>
           <a:xfrm>
-            <a:off x="1463040" y="4169664"/>
-            <a:ext cx="4312768" cy="1502664"/>
+            <a:off x="1417320" y="3985260"/>
+            <a:ext cx="4404208" cy="1546860"/>
           </a:xfrm>
           <a:prstGeom prst="rect">
             <a:avLst/>
@@ -6532,12 +6532,12 @@
         </p:nvSpPr>
         <p:spPr>
           <a:xfrm>
-            <a:off x="6233008" y="3986784"/>
-            <a:ext cx="5501488" cy="1868424"/>
+            <a:off x="6233008" y="3848100"/>
+            <a:ext cx="5501488" cy="1821180"/>
           </a:xfrm>
           <a:prstGeom prst="roundRect">
             <a:avLst>
-              <a:gd name="adj" fmla="val 5873"/>
+              <a:gd name="adj" fmla="val 6025"/>
             </a:avLst>
           </a:prstGeom>
           <a:solidFill>
@@ -6559,7 +6559,7 @@
         </p:nvSpPr>
         <p:spPr>
           <a:xfrm>
-            <a:off x="6415888" y="4169664"/>
+            <a:off x="6370168" y="3985260"/>
             <a:ext cx="640080" cy="640080"/>
           </a:xfrm>
           <a:prstGeom prst="ellipse">
@@ -6587,7 +6587,7 @@
         </p:blipFill>
         <p:spPr>
           <a:xfrm>
-            <a:off x="6575908" y="4329684"/>
+            <a:off x="6530188" y="4145280"/>
             <a:ext cx="320040" cy="320040"/>
           </a:xfrm>
           <a:prstGeom prst="rect">
@@ -6603,8 +6603,8 @@
         </p:nvSpPr>
         <p:spPr>
           <a:xfrm>
-            <a:off x="7238848" y="4169664"/>
-            <a:ext cx="4312768" cy="1502664"/>
+            <a:off x="7193128" y="3985260"/>
+            <a:ext cx="4404208" cy="1546860"/>
           </a:xfrm>
           <a:prstGeom prst="rect">
             <a:avLst/>
@@ -6798,7 +6798,7 @@
               <a:buNone/>
             </a:pPr>
             <a:r>
-              <a:rPr lang="en-US" sz="3400" b="1" dirty="0">
+              <a:rPr lang="en-US" sz="3200" b="1" dirty="0">
                 <a:solidFill>
                   <a:schemeClr val="tx2"/>
                 </a:solidFill>
@@ -7458,7 +7458,7 @@
         <p:spPr>
           <a:xfrm>
             <a:off x="457200" y="1417320"/>
-            <a:ext cx="3576218" cy="3703320"/>
+            <a:ext cx="3576218" cy="3794760"/>
           </a:xfrm>
           <a:prstGeom prst="roundRect">
             <a:avLst>
@@ -7479,8 +7479,8 @@
         </p:nvSpPr>
         <p:spPr>
           <a:xfrm>
-            <a:off x="685800" y="1645920"/>
-            <a:ext cx="640080" cy="640080"/>
+            <a:off x="685800" y="1668780"/>
+            <a:ext cx="502920" cy="502920"/>
           </a:xfrm>
           <a:prstGeom prst="ellipse">
             <a:avLst/>
@@ -7507,8 +7507,8 @@
         </p:blipFill>
         <p:spPr>
           <a:xfrm>
-            <a:off x="845820" y="1805940"/>
-            <a:ext cx="320040" cy="320040"/>
+            <a:off x="811530" y="1794510"/>
+            <a:ext cx="251460" cy="251460"/>
           </a:xfrm>
           <a:prstGeom prst="rect">
             <a:avLst/>
@@ -7523,8 +7523,8 @@
         </p:nvSpPr>
         <p:spPr>
           <a:xfrm>
-            <a:off x="1508760" y="1645920"/>
-            <a:ext cx="2296058" cy="640080"/>
+            <a:off x="1371600" y="1645920"/>
+            <a:ext cx="2433218" cy="548640"/>
           </a:xfrm>
           <a:prstGeom prst="rect">
             <a:avLst/>
@@ -7540,7 +7540,7 @@
               <a:buNone/>
             </a:pPr>
             <a:r>
-              <a:rPr lang="en-US" sz="2000" b="1" dirty="0">
+              <a:rPr lang="en-US" sz="1800" b="1" dirty="0">
                 <a:solidFill>
                   <a:schemeClr val="tx2"/>
                 </a:solidFill>
@@ -7550,7 +7550,7 @@
               </a:rPr>
               <a:t>C, areas</a:t>
             </a:r>
-            <a:endParaRPr lang="en-US" sz="2000" dirty="0"/>
+            <a:endParaRPr lang="en-US" sz="1800" dirty="0"/>
           </a:p>
         </p:txBody>
       </p:sp>
@@ -7562,8 +7562,8 @@
         </p:nvSpPr>
         <p:spPr>
           <a:xfrm>
-            <a:off x="685800" y="2468880"/>
-            <a:ext cx="3119018" cy="2423160"/>
+            <a:off x="685800" y="2286000"/>
+            <a:ext cx="3119018" cy="2834640"/>
           </a:xfrm>
           <a:prstGeom prst="rect">
             <a:avLst/>
@@ -7577,7 +7577,7 @@
           <a:p>
             <a:pPr algn="l" marL="177800" indent="-177800">
               <a:spcAft>
-                <a:spcPts val="600"/>
+                <a:spcPts val="400"/>
               </a:spcAft>
               <a:buSzPct val="100000"/>
               <a:buChar char="•"/>
@@ -7595,7 +7595,7 @@
           <a:p>
             <a:pPr algn="l" marL="177800" indent="-177800">
               <a:spcAft>
-                <a:spcPts val="600"/>
+                <a:spcPts val="400"/>
               </a:spcAft>
               <a:buSzPct val="100000"/>
               <a:buChar char="•"/>
@@ -7613,7 +7613,7 @@
           <a:p>
             <a:pPr algn="l" marL="177800" indent="-177800">
               <a:spcAft>
-                <a:spcPts val="600"/>
+                <a:spcPts val="400"/>
               </a:spcAft>
               <a:buSzPct val="100000"/>
               <a:buChar char="•"/>
@@ -7639,7 +7639,7 @@
         <p:spPr>
           <a:xfrm>
             <a:off x="4307738" y="1417320"/>
-            <a:ext cx="3576218" cy="3703320"/>
+            <a:ext cx="3576218" cy="3794760"/>
           </a:xfrm>
           <a:prstGeom prst="roundRect">
             <a:avLst>
@@ -7660,8 +7660,8 @@
         </p:nvSpPr>
         <p:spPr>
           <a:xfrm>
-            <a:off x="4536338" y="1645920"/>
-            <a:ext cx="640080" cy="640080"/>
+            <a:off x="4536338" y="1668780"/>
+            <a:ext cx="502920" cy="502920"/>
           </a:xfrm>
           <a:prstGeom prst="ellipse">
             <a:avLst/>
@@ -7688,8 +7688,8 @@
         </p:blipFill>
         <p:spPr>
           <a:xfrm>
-            <a:off x="4696358" y="1805940"/>
-            <a:ext cx="320040" cy="320040"/>
+            <a:off x="4662068" y="1794510"/>
+            <a:ext cx="251460" cy="251460"/>
           </a:xfrm>
           <a:prstGeom prst="rect">
             <a:avLst/>
@@ -7704,8 +7704,8 @@
         </p:nvSpPr>
         <p:spPr>
           <a:xfrm>
-            <a:off x="5359298" y="1645920"/>
-            <a:ext cx="2296058" cy="640080"/>
+            <a:off x="5222138" y="1645920"/>
+            <a:ext cx="2433218" cy="548640"/>
           </a:xfrm>
           <a:prstGeom prst="rect">
             <a:avLst/>
@@ -7721,7 +7721,7 @@
               <a:buNone/>
             </a:pPr>
             <a:r>
-              <a:rPr lang="en-US" sz="2000" b="1" dirty="0">
+              <a:rPr lang="en-US" sz="1800" b="1" dirty="0">
                 <a:solidFill>
                   <a:schemeClr val="tx2"/>
                 </a:solidFill>
@@ -7731,7 +7731,7 @@
               </a:rPr>
               <a:t>D, detection trials</a:t>
             </a:r>
-            <a:endParaRPr lang="en-US" sz="2000" dirty="0"/>
+            <a:endParaRPr lang="en-US" sz="1800" dirty="0"/>
           </a:p>
         </p:txBody>
       </p:sp>
@@ -7743,8 +7743,8 @@
         </p:nvSpPr>
         <p:spPr>
           <a:xfrm>
-            <a:off x="4536338" y="2468880"/>
-            <a:ext cx="3119018" cy="2423160"/>
+            <a:off x="4536338" y="2286000"/>
+            <a:ext cx="3119018" cy="2834640"/>
           </a:xfrm>
           <a:prstGeom prst="rect">
             <a:avLst/>
@@ -7758,7 +7758,7 @@
           <a:p>
             <a:pPr algn="l" marL="177800" indent="-177800">
               <a:spcAft>
-                <a:spcPts val="600"/>
+                <a:spcPts val="400"/>
               </a:spcAft>
               <a:buSzPct val="100000"/>
               <a:buChar char="•"/>
@@ -7776,7 +7776,7 @@
           <a:p>
             <a:pPr algn="l" marL="177800" indent="-177800">
               <a:spcAft>
-                <a:spcPts val="600"/>
+                <a:spcPts val="400"/>
               </a:spcAft>
               <a:buSzPct val="100000"/>
               <a:buChar char="•"/>
@@ -7794,7 +7794,7 @@
           <a:p>
             <a:pPr algn="l" marL="177800" indent="-177800">
               <a:spcAft>
-                <a:spcPts val="600"/>
+                <a:spcPts val="400"/>
               </a:spcAft>
               <a:buSzPct val="100000"/>
               <a:buChar char="•"/>
@@ -7820,7 +7820,7 @@
         <p:spPr>
           <a:xfrm>
             <a:off x="8158277" y="1417320"/>
-            <a:ext cx="3576218" cy="3703320"/>
+            <a:ext cx="3576218" cy="3794760"/>
           </a:xfrm>
           <a:prstGeom prst="roundRect">
             <a:avLst>
@@ -7841,8 +7841,8 @@
         </p:nvSpPr>
         <p:spPr>
           <a:xfrm>
-            <a:off x="8386877" y="1645920"/>
-            <a:ext cx="640080" cy="640080"/>
+            <a:off x="8386877" y="1668780"/>
+            <a:ext cx="502920" cy="502920"/>
           </a:xfrm>
           <a:prstGeom prst="ellipse">
             <a:avLst/>
@@ -7869,8 +7869,8 @@
         </p:blipFill>
         <p:spPr>
           <a:xfrm>
-            <a:off x="8546897" y="1805940"/>
-            <a:ext cx="320040" cy="320040"/>
+            <a:off x="8512607" y="1794510"/>
+            <a:ext cx="251460" cy="251460"/>
           </a:xfrm>
           <a:prstGeom prst="rect">
             <a:avLst/>
@@ -7885,8 +7885,8 @@
         </p:nvSpPr>
         <p:spPr>
           <a:xfrm>
-            <a:off x="9209837" y="1645920"/>
-            <a:ext cx="2296058" cy="640080"/>
+            <a:off x="9072677" y="1645920"/>
+            <a:ext cx="2433218" cy="548640"/>
           </a:xfrm>
           <a:prstGeom prst="rect">
             <a:avLst/>
@@ -7902,7 +7902,7 @@
               <a:buNone/>
             </a:pPr>
             <a:r>
-              <a:rPr lang="en-US" sz="2000" b="1" dirty="0">
+              <a:rPr lang="en-US" sz="1800" b="1" dirty="0">
                 <a:solidFill>
                   <a:schemeClr val="tx2"/>
                 </a:solidFill>
@@ -7912,7 +7912,7 @@
               </a:rPr>
               <a:t>Rules</a:t>
             </a:r>
-            <a:endParaRPr lang="en-US" sz="2000" dirty="0"/>
+            <a:endParaRPr lang="en-US" sz="1800" dirty="0"/>
           </a:p>
         </p:txBody>
       </p:sp>
@@ -7924,8 +7924,8 @@
         </p:nvSpPr>
         <p:spPr>
           <a:xfrm>
-            <a:off x="8386877" y="2468880"/>
-            <a:ext cx="3119018" cy="2423160"/>
+            <a:off x="8386877" y="2286000"/>
+            <a:ext cx="3119018" cy="2834640"/>
           </a:xfrm>
           <a:prstGeom prst="rect">
             <a:avLst/>
@@ -7939,7 +7939,7 @@
           <a:p>
             <a:pPr algn="l" marL="177800" indent="-177800">
               <a:spcAft>
-                <a:spcPts val="600"/>
+                <a:spcPts val="400"/>
               </a:spcAft>
               <a:buSzPct val="100000"/>
               <a:buChar char="•"/>
@@ -7957,7 +7957,7 @@
           <a:p>
             <a:pPr algn="l" marL="177800" indent="-177800">
               <a:spcAft>
-                <a:spcPts val="600"/>
+                <a:spcPts val="400"/>
               </a:spcAft>
               <a:buSzPct val="100000"/>
               <a:buChar char="•"/>
@@ -7975,7 +7975,7 @@
           <a:p>
             <a:pPr algn="l" marL="177800" indent="-177800">
               <a:spcAft>
-                <a:spcPts val="600"/>
+                <a:spcPts val="400"/>
               </a:spcAft>
               <a:buSzPct val="100000"/>
               <a:buChar char="•"/>
@@ -8918,11 +8918,11 @@
         <p:spPr>
           <a:xfrm>
             <a:off x="457200" y="1417320"/>
-            <a:ext cx="3576218" cy="2173224"/>
+            <a:ext cx="3576218" cy="2081784"/>
           </a:xfrm>
           <a:prstGeom prst="roundRect">
             <a:avLst>
-              <a:gd name="adj" fmla="val 5049"/>
+              <a:gd name="adj" fmla="val 5271"/>
             </a:avLst>
           </a:prstGeom>
           <a:solidFill>
@@ -8944,7 +8944,7 @@
         </p:nvSpPr>
         <p:spPr>
           <a:xfrm>
-            <a:off x="640080" y="1600200"/>
+            <a:off x="594360" y="1554480"/>
             <a:ext cx="640080" cy="640080"/>
           </a:xfrm>
           <a:prstGeom prst="ellipse">
@@ -8972,7 +8972,7 @@
         </p:blipFill>
         <p:spPr>
           <a:xfrm>
-            <a:off x="800100" y="1760220"/>
+            <a:off x="754380" y="1714500"/>
             <a:ext cx="320040" cy="320040"/>
           </a:xfrm>
           <a:prstGeom prst="rect">
@@ -8988,8 +8988,8 @@
         </p:nvSpPr>
         <p:spPr>
           <a:xfrm>
-            <a:off x="1463040" y="1600200"/>
-            <a:ext cx="2387498" cy="1807464"/>
+            <a:off x="1417320" y="1554480"/>
+            <a:ext cx="2478938" cy="1807464"/>
           </a:xfrm>
           <a:prstGeom prst="rect">
             <a:avLst/>
@@ -9059,11 +9059,11 @@
         <p:spPr>
           <a:xfrm>
             <a:off x="4307738" y="1417320"/>
-            <a:ext cx="3576218" cy="2173224"/>
+            <a:ext cx="3576218" cy="2081784"/>
           </a:xfrm>
           <a:prstGeom prst="roundRect">
             <a:avLst>
-              <a:gd name="adj" fmla="val 5049"/>
+              <a:gd name="adj" fmla="val 5271"/>
             </a:avLst>
           </a:prstGeom>
           <a:solidFill>
@@ -9085,7 +9085,7 @@
         </p:nvSpPr>
         <p:spPr>
           <a:xfrm>
-            <a:off x="4490618" y="1600200"/>
+            <a:off x="4444898" y="1554480"/>
             <a:ext cx="640080" cy="640080"/>
           </a:xfrm>
           <a:prstGeom prst="ellipse">
@@ -9113,7 +9113,7 @@
         </p:blipFill>
         <p:spPr>
           <a:xfrm>
-            <a:off x="4650638" y="1760220"/>
+            <a:off x="4604918" y="1714500"/>
             <a:ext cx="320040" cy="320040"/>
           </a:xfrm>
           <a:prstGeom prst="rect">
@@ -9129,8 +9129,8 @@
         </p:nvSpPr>
         <p:spPr>
           <a:xfrm>
-            <a:off x="5313578" y="1600200"/>
-            <a:ext cx="2387498" cy="1807464"/>
+            <a:off x="5267858" y="1554480"/>
+            <a:ext cx="2478938" cy="1807464"/>
           </a:xfrm>
           <a:prstGeom prst="rect">
             <a:avLst/>
@@ -9200,11 +9200,11 @@
         <p:spPr>
           <a:xfrm>
             <a:off x="8158277" y="1417320"/>
-            <a:ext cx="3576218" cy="2173224"/>
+            <a:ext cx="3576218" cy="2081784"/>
           </a:xfrm>
           <a:prstGeom prst="roundRect">
             <a:avLst>
-              <a:gd name="adj" fmla="val 5049"/>
+              <a:gd name="adj" fmla="val 5271"/>
             </a:avLst>
           </a:prstGeom>
           <a:solidFill>
@@ -9226,7 +9226,7 @@
         </p:nvSpPr>
         <p:spPr>
           <a:xfrm>
-            <a:off x="8341157" y="1600200"/>
+            <a:off x="8295437" y="1554480"/>
             <a:ext cx="640080" cy="640080"/>
           </a:xfrm>
           <a:prstGeom prst="ellipse">
@@ -9254,7 +9254,7 @@
         </p:blipFill>
         <p:spPr>
           <a:xfrm>
-            <a:off x="8501177" y="1760220"/>
+            <a:off x="8455457" y="1714500"/>
             <a:ext cx="320040" cy="320040"/>
           </a:xfrm>
           <a:prstGeom prst="rect">
@@ -9270,8 +9270,8 @@
         </p:nvSpPr>
         <p:spPr>
           <a:xfrm>
-            <a:off x="9164117" y="1600200"/>
-            <a:ext cx="2387498" cy="1807464"/>
+            <a:off x="9118397" y="1554480"/>
+            <a:ext cx="2478938" cy="1807464"/>
           </a:xfrm>
           <a:prstGeom prst="rect">
             <a:avLst/>
@@ -9340,12 +9340,12 @@
         </p:nvSpPr>
         <p:spPr>
           <a:xfrm>
-            <a:off x="457200" y="3864864"/>
-            <a:ext cx="5501488" cy="1898904"/>
+            <a:off x="457200" y="3681984"/>
+            <a:ext cx="5501488" cy="1807464"/>
           </a:xfrm>
           <a:prstGeom prst="roundRect">
             <a:avLst>
-              <a:gd name="adj" fmla="val 5778"/>
+              <a:gd name="adj" fmla="val 6071"/>
             </a:avLst>
           </a:prstGeom>
           <a:solidFill>
@@ -9367,7 +9367,7 @@
         </p:nvSpPr>
         <p:spPr>
           <a:xfrm>
-            <a:off x="640080" y="4047744"/>
+            <a:off x="594360" y="3819144"/>
             <a:ext cx="640080" cy="640080"/>
           </a:xfrm>
           <a:prstGeom prst="ellipse">
@@ -9395,7 +9395,7 @@
         </p:blipFill>
         <p:spPr>
           <a:xfrm>
-            <a:off x="800100" y="4207764"/>
+            <a:off x="754380" y="3979164"/>
             <a:ext cx="320040" cy="320040"/>
           </a:xfrm>
           <a:prstGeom prst="rect">
@@ -9411,8 +9411,8 @@
         </p:nvSpPr>
         <p:spPr>
           <a:xfrm>
-            <a:off x="1463040" y="4047744"/>
-            <a:ext cx="4312768" cy="1533144"/>
+            <a:off x="1417320" y="3819144"/>
+            <a:ext cx="4404208" cy="1533144"/>
           </a:xfrm>
           <a:prstGeom prst="rect">
             <a:avLst/>
@@ -9481,12 +9481,12 @@
         </p:nvSpPr>
         <p:spPr>
           <a:xfrm>
-            <a:off x="6233008" y="3864864"/>
-            <a:ext cx="5501488" cy="1898904"/>
+            <a:off x="6233008" y="3681984"/>
+            <a:ext cx="5501488" cy="1807464"/>
           </a:xfrm>
           <a:prstGeom prst="roundRect">
             <a:avLst>
-              <a:gd name="adj" fmla="val 5778"/>
+              <a:gd name="adj" fmla="val 6071"/>
             </a:avLst>
           </a:prstGeom>
           <a:solidFill>
@@ -9508,7 +9508,7 @@
         </p:nvSpPr>
         <p:spPr>
           <a:xfrm>
-            <a:off x="6415888" y="4047744"/>
+            <a:off x="6370168" y="3819144"/>
             <a:ext cx="640080" cy="640080"/>
           </a:xfrm>
           <a:prstGeom prst="ellipse">
@@ -9536,7 +9536,7 @@
         </p:blipFill>
         <p:spPr>
           <a:xfrm>
-            <a:off x="6575908" y="4207764"/>
+            <a:off x="6530188" y="3979164"/>
             <a:ext cx="320040" cy="320040"/>
           </a:xfrm>
           <a:prstGeom prst="rect">
@@ -9552,8 +9552,8 @@
         </p:nvSpPr>
         <p:spPr>
           <a:xfrm>
-            <a:off x="7238848" y="4047744"/>
-            <a:ext cx="4312768" cy="1533144"/>
+            <a:off x="7193128" y="3819144"/>
+            <a:ext cx="4404208" cy="1533144"/>
           </a:xfrm>
           <a:prstGeom prst="rect">
             <a:avLst/>
@@ -9770,11 +9770,11 @@
         <p:spPr>
           <a:xfrm>
             <a:off x="457200" y="1417320"/>
-            <a:ext cx="5501488" cy="960120"/>
+            <a:ext cx="5501488" cy="1040130"/>
           </a:xfrm>
           <a:prstGeom prst="roundRect">
             <a:avLst>
-              <a:gd name="adj" fmla="val 11429"/>
+              <a:gd name="adj" fmla="val 10549"/>
             </a:avLst>
           </a:prstGeom>
           <a:solidFill>
@@ -9791,7 +9791,7 @@
         </p:nvSpPr>
         <p:spPr>
           <a:xfrm>
-            <a:off x="640080" y="1600200"/>
+            <a:off x="640080" y="1640205"/>
             <a:ext cx="594360" cy="594360"/>
           </a:xfrm>
           <a:prstGeom prst="ellipse">
@@ -9819,7 +9819,7 @@
         </p:blipFill>
         <p:spPr>
           <a:xfrm>
-            <a:off x="788670" y="1748790"/>
+            <a:off x="788670" y="1788795"/>
             <a:ext cx="297180" cy="297180"/>
           </a:xfrm>
           <a:prstGeom prst="rect">
@@ -9836,7 +9836,7 @@
         <p:spPr>
           <a:xfrm>
             <a:off x="1417320" y="1417320"/>
-            <a:ext cx="4358488" cy="960120"/>
+            <a:ext cx="4358488" cy="1040130"/>
           </a:xfrm>
           <a:prstGeom prst="rect">
             <a:avLst/>
@@ -9871,12 +9871,12 @@
         </p:nvSpPr>
         <p:spPr>
           <a:xfrm>
-            <a:off x="457200" y="2560320"/>
-            <a:ext cx="5501488" cy="960120"/>
+            <a:off x="457200" y="2640330"/>
+            <a:ext cx="5501488" cy="1040130"/>
           </a:xfrm>
           <a:prstGeom prst="roundRect">
             <a:avLst>
-              <a:gd name="adj" fmla="val 11429"/>
+              <a:gd name="adj" fmla="val 10549"/>
             </a:avLst>
           </a:prstGeom>
           <a:solidFill>
@@ -9893,7 +9893,7 @@
         </p:nvSpPr>
         <p:spPr>
           <a:xfrm>
-            <a:off x="640080" y="2743200"/>
+            <a:off x="640080" y="2863215"/>
             <a:ext cx="594360" cy="594360"/>
           </a:xfrm>
           <a:prstGeom prst="ellipse">
@@ -9921,7 +9921,7 @@
         </p:blipFill>
         <p:spPr>
           <a:xfrm>
-            <a:off x="788670" y="2891790"/>
+            <a:off x="788670" y="3011805"/>
             <a:ext cx="297180" cy="297180"/>
           </a:xfrm>
           <a:prstGeom prst="rect">
@@ -9937,8 +9937,8 @@
         </p:nvSpPr>
         <p:spPr>
           <a:xfrm>
-            <a:off x="1417320" y="2560320"/>
-            <a:ext cx="4358488" cy="960120"/>
+            <a:off x="1417320" y="2640330"/>
+            <a:ext cx="4358488" cy="1040130"/>
           </a:xfrm>
           <a:prstGeom prst="rect">
             <a:avLst/>
@@ -9973,7 +9973,7 @@
         </p:nvSpPr>
         <p:spPr>
           <a:xfrm>
-            <a:off x="457200" y="3703320"/>
+            <a:off x="457200" y="3863340"/>
             <a:ext cx="5501488" cy="1152144"/>
           </a:xfrm>
           <a:prstGeom prst="roundRect">
@@ -9995,7 +9995,7 @@
         </p:nvSpPr>
         <p:spPr>
           <a:xfrm>
-            <a:off x="640080" y="3982212"/>
+            <a:off x="640080" y="4142232"/>
             <a:ext cx="594360" cy="594360"/>
           </a:xfrm>
           <a:prstGeom prst="ellipse">
@@ -10023,7 +10023,7 @@
         </p:blipFill>
         <p:spPr>
           <a:xfrm>
-            <a:off x="788670" y="4130802"/>
+            <a:off x="788670" y="4290822"/>
             <a:ext cx="297180" cy="297180"/>
           </a:xfrm>
           <a:prstGeom prst="rect">
@@ -10039,7 +10039,7 @@
         </p:nvSpPr>
         <p:spPr>
           <a:xfrm>
-            <a:off x="1417320" y="3703320"/>
+            <a:off x="1417320" y="3863340"/>
             <a:ext cx="4358488" cy="1152144"/>
           </a:xfrm>
           <a:prstGeom prst="rect">
@@ -10075,7 +10075,7 @@
         </p:nvSpPr>
         <p:spPr>
           <a:xfrm>
-            <a:off x="457200" y="5038344"/>
+            <a:off x="457200" y="5198364"/>
             <a:ext cx="5501488" cy="1152144"/>
           </a:xfrm>
           <a:prstGeom prst="roundRect">
@@ -10097,7 +10097,7 @@
         </p:nvSpPr>
         <p:spPr>
           <a:xfrm>
-            <a:off x="640080" y="5317236"/>
+            <a:off x="640080" y="5477256"/>
             <a:ext cx="594360" cy="594360"/>
           </a:xfrm>
           <a:prstGeom prst="ellipse">
@@ -10125,7 +10125,7 @@
         </p:blipFill>
         <p:spPr>
           <a:xfrm>
-            <a:off x="788670" y="5465826"/>
+            <a:off x="788670" y="5625846"/>
             <a:ext cx="297180" cy="297180"/>
           </a:xfrm>
           <a:prstGeom prst="rect">
@@ -10141,7 +10141,7 @@
         </p:nvSpPr>
         <p:spPr>
           <a:xfrm>
-            <a:off x="1417320" y="5038344"/>
+            <a:off x="1417320" y="5198364"/>
             <a:ext cx="4358488" cy="1152144"/>
           </a:xfrm>
           <a:prstGeom prst="rect">
@@ -10595,7 +10595,7 @@
         <p:spPr>
           <a:xfrm>
             <a:off x="457200" y="1417320"/>
-            <a:ext cx="3576218" cy="3703320"/>
+            <a:ext cx="3576218" cy="3794760"/>
           </a:xfrm>
           <a:prstGeom prst="roundRect">
             <a:avLst>
@@ -10616,8 +10616,8 @@
         </p:nvSpPr>
         <p:spPr>
           <a:xfrm>
-            <a:off x="685800" y="1645920"/>
-            <a:ext cx="640080" cy="640080"/>
+            <a:off x="685800" y="1668780"/>
+            <a:ext cx="502920" cy="502920"/>
           </a:xfrm>
           <a:prstGeom prst="ellipse">
             <a:avLst/>
@@ -10644,8 +10644,8 @@
         </p:blipFill>
         <p:spPr>
           <a:xfrm>
-            <a:off x="845820" y="1805940"/>
-            <a:ext cx="320040" cy="320040"/>
+            <a:off x="811530" y="1794510"/>
+            <a:ext cx="251460" cy="251460"/>
           </a:xfrm>
           <a:prstGeom prst="rect">
             <a:avLst/>
@@ -10660,8 +10660,8 @@
         </p:nvSpPr>
         <p:spPr>
           <a:xfrm>
-            <a:off x="1508760" y="1645920"/>
-            <a:ext cx="2296058" cy="640080"/>
+            <a:off x="1371600" y="1645920"/>
+            <a:ext cx="2433218" cy="548640"/>
           </a:xfrm>
           <a:prstGeom prst="rect">
             <a:avLst/>
@@ -10677,7 +10677,7 @@
               <a:buNone/>
             </a:pPr>
             <a:r>
-              <a:rPr lang="en-US" sz="2000" b="1" dirty="0">
+              <a:rPr lang="en-US" sz="1800" b="1" dirty="0">
                 <a:solidFill>
                   <a:schemeClr val="tx2"/>
                 </a:solidFill>
@@ -10687,7 +10687,7 @@
               </a:rPr>
               <a:t>The five series</a:t>
             </a:r>
-            <a:endParaRPr lang="en-US" sz="2000" dirty="0"/>
+            <a:endParaRPr lang="en-US" sz="1800" dirty="0"/>
           </a:p>
         </p:txBody>
       </p:sp>
@@ -10699,8 +10699,8 @@
         </p:nvSpPr>
         <p:spPr>
           <a:xfrm>
-            <a:off x="685800" y="2468880"/>
-            <a:ext cx="3119018" cy="2423160"/>
+            <a:off x="685800" y="2286000"/>
+            <a:ext cx="3119018" cy="2834640"/>
           </a:xfrm>
           <a:prstGeom prst="rect">
             <a:avLst/>
@@ -10714,7 +10714,7 @@
           <a:p>
             <a:pPr algn="l" marL="177800" indent="-177800">
               <a:spcAft>
-                <a:spcPts val="600"/>
+                <a:spcPts val="400"/>
               </a:spcAft>
               <a:buSzPct val="100000"/>
               <a:buChar char="•"/>
@@ -10732,7 +10732,7 @@
           <a:p>
             <a:pPr algn="l" marL="177800" indent="-177800">
               <a:spcAft>
-                <a:spcPts val="600"/>
+                <a:spcPts val="400"/>
               </a:spcAft>
               <a:buSzPct val="100000"/>
               <a:buChar char="•"/>
@@ -10750,7 +10750,7 @@
           <a:p>
             <a:pPr algn="l" marL="177800" indent="-177800">
               <a:spcAft>
-                <a:spcPts val="600"/>
+                <a:spcPts val="400"/>
               </a:spcAft>
               <a:buSzPct val="100000"/>
               <a:buChar char="•"/>
@@ -10768,7 +10768,7 @@
           <a:p>
             <a:pPr algn="l" marL="177800" indent="-177800">
               <a:spcAft>
-                <a:spcPts val="600"/>
+                <a:spcPts val="400"/>
               </a:spcAft>
               <a:buSzPct val="100000"/>
               <a:buChar char="•"/>
@@ -10786,7 +10786,7 @@
           <a:p>
             <a:pPr algn="l" marL="177800" indent="-177800">
               <a:spcAft>
-                <a:spcPts val="600"/>
+                <a:spcPts val="400"/>
               </a:spcAft>
               <a:buSzPct val="100000"/>
               <a:buChar char="•"/>
@@ -10812,7 +10812,7 @@
         <p:spPr>
           <a:xfrm>
             <a:off x="4307738" y="1417320"/>
-            <a:ext cx="3576218" cy="3703320"/>
+            <a:ext cx="3576218" cy="3794760"/>
           </a:xfrm>
           <a:prstGeom prst="roundRect">
             <a:avLst>
@@ -10833,8 +10833,8 @@
         </p:nvSpPr>
         <p:spPr>
           <a:xfrm>
-            <a:off x="4536338" y="1645920"/>
-            <a:ext cx="640080" cy="640080"/>
+            <a:off x="4536338" y="1668780"/>
+            <a:ext cx="502920" cy="502920"/>
           </a:xfrm>
           <a:prstGeom prst="ellipse">
             <a:avLst/>
@@ -10861,8 +10861,8 @@
         </p:blipFill>
         <p:spPr>
           <a:xfrm>
-            <a:off x="4696358" y="1805940"/>
-            <a:ext cx="320040" cy="320040"/>
+            <a:off x="4662068" y="1794510"/>
+            <a:ext cx="251460" cy="251460"/>
           </a:xfrm>
           <a:prstGeom prst="rect">
             <a:avLst/>
@@ -10877,8 +10877,8 @@
         </p:nvSpPr>
         <p:spPr>
           <a:xfrm>
-            <a:off x="5359298" y="1645920"/>
-            <a:ext cx="2296058" cy="640080"/>
+            <a:off x="5222138" y="1645920"/>
+            <a:ext cx="2433218" cy="548640"/>
           </a:xfrm>
           <a:prstGeom prst="rect">
             <a:avLst/>
@@ -10894,7 +10894,7 @@
               <a:buNone/>
             </a:pPr>
             <a:r>
-              <a:rPr lang="en-US" sz="2000" b="1" dirty="0">
+              <a:rPr lang="en-US" sz="1800" b="1" dirty="0">
                 <a:solidFill>
                   <a:schemeClr val="tx2"/>
                 </a:solidFill>
@@ -10904,7 +10904,7 @@
               </a:rPr>
               <a:t>What the robot gives us</a:t>
             </a:r>
-            <a:endParaRPr lang="en-US" sz="2000" dirty="0"/>
+            <a:endParaRPr lang="en-US" sz="1800" dirty="0"/>
           </a:p>
         </p:txBody>
       </p:sp>
@@ -10916,8 +10916,8 @@
         </p:nvSpPr>
         <p:spPr>
           <a:xfrm>
-            <a:off x="4536338" y="2468880"/>
-            <a:ext cx="3119018" cy="2423160"/>
+            <a:off x="4536338" y="2286000"/>
+            <a:ext cx="3119018" cy="2834640"/>
           </a:xfrm>
           <a:prstGeom prst="rect">
             <a:avLst/>
@@ -10931,7 +10931,7 @@
           <a:p>
             <a:pPr algn="l" marL="177800" indent="-177800">
               <a:spcAft>
-                <a:spcPts val="600"/>
+                <a:spcPts val="400"/>
               </a:spcAft>
               <a:buSzPct val="100000"/>
               <a:buChar char="•"/>
@@ -10949,7 +10949,7 @@
           <a:p>
             <a:pPr algn="l" marL="177800" indent="-177800">
               <a:spcAft>
-                <a:spcPts val="600"/>
+                <a:spcPts val="400"/>
               </a:spcAft>
               <a:buSzPct val="100000"/>
               <a:buChar char="•"/>
@@ -10967,7 +10967,7 @@
           <a:p>
             <a:pPr algn="l" marL="177800" indent="-177800">
               <a:spcAft>
-                <a:spcPts val="600"/>
+                <a:spcPts val="400"/>
               </a:spcAft>
               <a:buSzPct val="100000"/>
               <a:buChar char="•"/>
@@ -10985,7 +10985,7 @@
           <a:p>
             <a:pPr algn="l" marL="177800" indent="-177800">
               <a:spcAft>
-                <a:spcPts val="600"/>
+                <a:spcPts val="400"/>
               </a:spcAft>
               <a:buSzPct val="100000"/>
               <a:buChar char="•"/>
@@ -11011,7 +11011,7 @@
         <p:spPr>
           <a:xfrm>
             <a:off x="8158277" y="1417320"/>
-            <a:ext cx="3576218" cy="3703320"/>
+            <a:ext cx="3576218" cy="3794760"/>
           </a:xfrm>
           <a:prstGeom prst="roundRect">
             <a:avLst>
@@ -11032,8 +11032,8 @@
         </p:nvSpPr>
         <p:spPr>
           <a:xfrm>
-            <a:off x="8386877" y="1645920"/>
-            <a:ext cx="640080" cy="640080"/>
+            <a:off x="8386877" y="1668780"/>
+            <a:ext cx="502920" cy="502920"/>
           </a:xfrm>
           <a:prstGeom prst="ellipse">
             <a:avLst/>
@@ -11060,8 +11060,8 @@
         </p:blipFill>
         <p:spPr>
           <a:xfrm>
-            <a:off x="8546897" y="1805940"/>
-            <a:ext cx="320040" cy="320040"/>
+            <a:off x="8512607" y="1794510"/>
+            <a:ext cx="251460" cy="251460"/>
           </a:xfrm>
           <a:prstGeom prst="rect">
             <a:avLst/>
@@ -11076,8 +11076,8 @@
         </p:nvSpPr>
         <p:spPr>
           <a:xfrm>
-            <a:off x="9209837" y="1645920"/>
-            <a:ext cx="2296058" cy="640080"/>
+            <a:off x="9072677" y="1645920"/>
+            <a:ext cx="2433218" cy="548640"/>
           </a:xfrm>
           <a:prstGeom prst="rect">
             <a:avLst/>
@@ -11093,7 +11093,7 @@
               <a:buNone/>
             </a:pPr>
             <a:r>
-              <a:rPr lang="en-US" sz="2000" b="1" dirty="0">
+              <a:rPr lang="en-US" sz="1800" b="1" dirty="0">
                 <a:solidFill>
                   <a:schemeClr val="tx2"/>
                 </a:solidFill>
@@ -11103,7 +11103,7 @@
               </a:rPr>
               <a:t>What the session produces</a:t>
             </a:r>
-            <a:endParaRPr lang="en-US" sz="2000" dirty="0"/>
+            <a:endParaRPr lang="en-US" sz="1800" dirty="0"/>
           </a:p>
         </p:txBody>
       </p:sp>
@@ -11115,8 +11115,8 @@
         </p:nvSpPr>
         <p:spPr>
           <a:xfrm>
-            <a:off x="8386877" y="2468880"/>
-            <a:ext cx="3119018" cy="2423160"/>
+            <a:off x="8386877" y="2286000"/>
+            <a:ext cx="3119018" cy="2834640"/>
           </a:xfrm>
           <a:prstGeom prst="rect">
             <a:avLst/>
@@ -11130,7 +11130,7 @@
           <a:p>
             <a:pPr algn="l" marL="177800" indent="-177800">
               <a:spcAft>
-                <a:spcPts val="600"/>
+                <a:spcPts val="400"/>
               </a:spcAft>
               <a:buSzPct val="100000"/>
               <a:buChar char="•"/>
@@ -11148,7 +11148,7 @@
           <a:p>
             <a:pPr algn="l" marL="177800" indent="-177800">
               <a:spcAft>
-                <a:spcPts val="600"/>
+                <a:spcPts val="400"/>
               </a:spcAft>
               <a:buSzPct val="100000"/>
               <a:buChar char="•"/>
@@ -11166,7 +11166,7 @@
           <a:p>
             <a:pPr algn="l" marL="177800" indent="-177800">
               <a:spcAft>
-                <a:spcPts val="600"/>
+                <a:spcPts val="400"/>
               </a:spcAft>
               <a:buSzPct val="100000"/>
               <a:buChar char="•"/>
@@ -12122,11 +12122,11 @@
         <p:spPr>
           <a:xfrm>
             <a:off x="457200" y="1417320"/>
-            <a:ext cx="3576218" cy="2560320"/>
+            <a:ext cx="3576218" cy="2377440"/>
           </a:xfrm>
           <a:prstGeom prst="roundRect">
             <a:avLst>
-              <a:gd name="adj" fmla="val 4286"/>
+              <a:gd name="adj" fmla="val 4615"/>
             </a:avLst>
           </a:prstGeom>
           <a:solidFill>
@@ -12227,7 +12227,7 @@
         <p:spPr>
           <a:xfrm>
             <a:off x="685800" y="3063240"/>
-            <a:ext cx="3119018" cy="548640"/>
+            <a:ext cx="3119018" cy="731520"/>
           </a:xfrm>
           <a:prstGeom prst="rect">
             <a:avLst/>
@@ -12263,11 +12263,11 @@
         <p:spPr>
           <a:xfrm>
             <a:off x="4307738" y="1417320"/>
-            <a:ext cx="3576218" cy="2560320"/>
+            <a:ext cx="3576218" cy="2377440"/>
           </a:xfrm>
           <a:prstGeom prst="roundRect">
             <a:avLst>
-              <a:gd name="adj" fmla="val 4286"/>
+              <a:gd name="adj" fmla="val 4615"/>
             </a:avLst>
           </a:prstGeom>
           <a:solidFill>
@@ -12368,7 +12368,7 @@
         <p:spPr>
           <a:xfrm>
             <a:off x="4536338" y="3063240"/>
-            <a:ext cx="3119018" cy="548640"/>
+            <a:ext cx="3119018" cy="731520"/>
           </a:xfrm>
           <a:prstGeom prst="rect">
             <a:avLst/>
@@ -12404,11 +12404,11 @@
         <p:spPr>
           <a:xfrm>
             <a:off x="8158277" y="1417320"/>
-            <a:ext cx="3576218" cy="2560320"/>
+            <a:ext cx="3576218" cy="2377440"/>
           </a:xfrm>
           <a:prstGeom prst="roundRect">
             <a:avLst>
-              <a:gd name="adj" fmla="val 4286"/>
+              <a:gd name="adj" fmla="val 4615"/>
             </a:avLst>
           </a:prstGeom>
           <a:solidFill>
@@ -12509,7 +12509,7 @@
         <p:spPr>
           <a:xfrm>
             <a:off x="8386877" y="3063240"/>
-            <a:ext cx="3119018" cy="548640"/>
+            <a:ext cx="3119018" cy="731520"/>
           </a:xfrm>
           <a:prstGeom prst="rect">
             <a:avLst/>
@@ -12544,7 +12544,7 @@
         </p:nvSpPr>
         <p:spPr>
           <a:xfrm>
-            <a:off x="457200" y="4297680"/>
+            <a:off x="457200" y="4160520"/>
             <a:ext cx="548640" cy="548640"/>
           </a:xfrm>
           <a:prstGeom prst="ellipse">
@@ -12572,7 +12572,7 @@
         </p:blipFill>
         <p:spPr>
           <a:xfrm>
-            <a:off x="594360" y="4434840"/>
+            <a:off x="594360" y="4297680"/>
             <a:ext cx="274320" cy="274320"/>
           </a:xfrm>
           <a:prstGeom prst="rect">
@@ -12588,8 +12588,8 @@
         </p:nvSpPr>
         <p:spPr>
           <a:xfrm>
-            <a:off x="1188720" y="4251960"/>
-            <a:ext cx="10545775" cy="640080"/>
+            <a:off x="1188720" y="4069080"/>
+            <a:ext cx="10545775" cy="731520"/>
           </a:xfrm>
           <a:prstGeom prst="rect">
             <a:avLst/>
@@ -12624,8 +12624,8 @@
         </p:nvSpPr>
         <p:spPr>
           <a:xfrm>
-            <a:off x="457200" y="5166360"/>
-            <a:ext cx="11277295" cy="960120"/>
+            <a:off x="457200" y="5074920"/>
+            <a:ext cx="11277295" cy="1051560"/>
           </a:xfrm>
           <a:prstGeom prst="rect">
             <a:avLst/>
@@ -12641,14 +12641,14 @@
               <a:buNone/>
             </a:pPr>
             <a:r>
-              <a:rPr lang="en-US" sz="2000" dirty="0">
+              <a:rPr lang="en-US" sz="1600" dirty="0">
                 <a:solidFill>
                   <a:schemeClr val="tx1"/>
                 </a:solidFill>
               </a:rPr>
               <a:t>The default plan is the capture budget of procedure section 13. Outside it are the optional captures the engineer plans only when needed: the filters-off repeat of A and B, the staircase of Z, the lateral sweep of B, the open-background variant of C, and the separate 8 hour drift run taken with the robot idle.</a:t>
             </a:r>
-            <a:endParaRPr lang="en-US" sz="2000" dirty="0"/>
+            <a:endParaRPr lang="en-US" sz="1600" dirty="0"/>
           </a:p>
         </p:txBody>
       </p:sp>
@@ -13996,7 +13996,7 @@
         <p:spPr>
           <a:xfrm>
             <a:off x="457200" y="1417320"/>
-            <a:ext cx="3576218" cy="3703320"/>
+            <a:ext cx="3576218" cy="3794760"/>
           </a:xfrm>
           <a:prstGeom prst="roundRect">
             <a:avLst>
@@ -14017,8 +14017,8 @@
         </p:nvSpPr>
         <p:spPr>
           <a:xfrm>
-            <a:off x="685800" y="1645920"/>
-            <a:ext cx="640080" cy="640080"/>
+            <a:off x="685800" y="1668780"/>
+            <a:ext cx="502920" cy="502920"/>
           </a:xfrm>
           <a:prstGeom prst="ellipse">
             <a:avLst/>
@@ -14045,8 +14045,8 @@
         </p:blipFill>
         <p:spPr>
           <a:xfrm>
-            <a:off x="845820" y="1805940"/>
-            <a:ext cx="320040" cy="320040"/>
+            <a:off x="811530" y="1794510"/>
+            <a:ext cx="251460" cy="251460"/>
           </a:xfrm>
           <a:prstGeom prst="rect">
             <a:avLst/>
@@ -14061,8 +14061,8 @@
         </p:nvSpPr>
         <p:spPr>
           <a:xfrm>
-            <a:off x="1508760" y="1645920"/>
-            <a:ext cx="2296058" cy="640080"/>
+            <a:off x="1371600" y="1645920"/>
+            <a:ext cx="2433218" cy="548640"/>
           </a:xfrm>
           <a:prstGeom prst="rect">
             <a:avLst/>
@@ -14078,7 +14078,7 @@
               <a:buNone/>
             </a:pPr>
             <a:r>
-              <a:rPr lang="en-US" sz="2000" b="1" dirty="0">
+              <a:rPr lang="en-US" sz="1800" b="1" dirty="0">
                 <a:solidFill>
                   <a:schemeClr val="tx2"/>
                 </a:solidFill>
@@ -14088,7 +14088,7 @@
               </a:rPr>
               <a:t>Robot</a:t>
             </a:r>
-            <a:endParaRPr lang="en-US" sz="2000" dirty="0"/>
+            <a:endParaRPr lang="en-US" sz="1800" dirty="0"/>
           </a:p>
         </p:txBody>
       </p:sp>
@@ -14100,8 +14100,8 @@
         </p:nvSpPr>
         <p:spPr>
           <a:xfrm>
-            <a:off x="685800" y="2468880"/>
-            <a:ext cx="3119018" cy="2423160"/>
+            <a:off x="685800" y="2286000"/>
+            <a:ext cx="3119018" cy="2834640"/>
           </a:xfrm>
           <a:prstGeom prst="rect">
             <a:avLst/>
@@ -14115,7 +14115,7 @@
           <a:p>
             <a:pPr algn="l" marL="177800" indent="-177800">
               <a:spcAft>
-                <a:spcPts val="600"/>
+                <a:spcPts val="400"/>
               </a:spcAft>
               <a:buSzPct val="100000"/>
               <a:buChar char="•"/>
@@ -14133,7 +14133,7 @@
           <a:p>
             <a:pPr algn="l" marL="177800" indent="-177800">
               <a:spcAft>
-                <a:spcPts val="600"/>
+                <a:spcPts val="400"/>
               </a:spcAft>
               <a:buSzPct val="100000"/>
               <a:buChar char="•"/>
@@ -14151,7 +14151,7 @@
           <a:p>
             <a:pPr algn="l" marL="177800" indent="-177800">
               <a:spcAft>
-                <a:spcPts val="600"/>
+                <a:spcPts val="400"/>
               </a:spcAft>
               <a:buSzPct val="100000"/>
               <a:buChar char="•"/>
@@ -14169,7 +14169,7 @@
           <a:p>
             <a:pPr algn="l" marL="177800" indent="-177800">
               <a:spcAft>
-                <a:spcPts val="600"/>
+                <a:spcPts val="400"/>
               </a:spcAft>
               <a:buSzPct val="100000"/>
               <a:buChar char="•"/>
@@ -14187,7 +14187,7 @@
           <a:p>
             <a:pPr algn="l" marL="177800" indent="-177800">
               <a:spcAft>
-                <a:spcPts val="600"/>
+                <a:spcPts val="400"/>
               </a:spcAft>
               <a:buSzPct val="100000"/>
               <a:buChar char="•"/>
@@ -14213,7 +14213,7 @@
         <p:spPr>
           <a:xfrm>
             <a:off x="4307738" y="1417320"/>
-            <a:ext cx="3576218" cy="3703320"/>
+            <a:ext cx="3576218" cy="3794760"/>
           </a:xfrm>
           <a:prstGeom prst="roundRect">
             <a:avLst>
@@ -14234,8 +14234,8 @@
         </p:nvSpPr>
         <p:spPr>
           <a:xfrm>
-            <a:off x="4536338" y="1645920"/>
-            <a:ext cx="640080" cy="640080"/>
+            <a:off x="4536338" y="1668780"/>
+            <a:ext cx="502920" cy="502920"/>
           </a:xfrm>
           <a:prstGeom prst="ellipse">
             <a:avLst/>
@@ -14262,8 +14262,8 @@
         </p:blipFill>
         <p:spPr>
           <a:xfrm>
-            <a:off x="4696358" y="1805940"/>
-            <a:ext cx="320040" cy="320040"/>
+            <a:off x="4662068" y="1794510"/>
+            <a:ext cx="251460" cy="251460"/>
           </a:xfrm>
           <a:prstGeom prst="rect">
             <a:avLst/>
@@ -14278,8 +14278,8 @@
         </p:nvSpPr>
         <p:spPr>
           <a:xfrm>
-            <a:off x="5359298" y="1645920"/>
-            <a:ext cx="2296058" cy="640080"/>
+            <a:off x="5222138" y="1645920"/>
+            <a:ext cx="2433218" cy="548640"/>
           </a:xfrm>
           <a:prstGeom prst="rect">
             <a:avLst/>
@@ -14295,7 +14295,7 @@
               <a:buNone/>
             </a:pPr>
             <a:r>
-              <a:rPr lang="en-US" sz="2000" b="1" dirty="0">
+              <a:rPr lang="en-US" sz="1800" b="1" dirty="0">
                 <a:solidFill>
                   <a:schemeClr val="tx2"/>
                 </a:solidFill>
@@ -14305,7 +14305,7 @@
               </a:rPr>
               <a:t>Sensor and computers</a:t>
             </a:r>
-            <a:endParaRPr lang="en-US" sz="2000" dirty="0"/>
+            <a:endParaRPr lang="en-US" sz="1800" dirty="0"/>
           </a:p>
         </p:txBody>
       </p:sp>
@@ -14317,8 +14317,8 @@
         </p:nvSpPr>
         <p:spPr>
           <a:xfrm>
-            <a:off x="4536338" y="2468880"/>
-            <a:ext cx="3119018" cy="2423160"/>
+            <a:off x="4536338" y="2286000"/>
+            <a:ext cx="3119018" cy="2834640"/>
           </a:xfrm>
           <a:prstGeom prst="rect">
             <a:avLst/>
@@ -14332,7 +14332,7 @@
           <a:p>
             <a:pPr algn="l" marL="177800" indent="-177800">
               <a:spcAft>
-                <a:spcPts val="600"/>
+                <a:spcPts val="400"/>
               </a:spcAft>
               <a:buSzPct val="100000"/>
               <a:buChar char="•"/>
@@ -14350,7 +14350,7 @@
           <a:p>
             <a:pPr algn="l" marL="177800" indent="-177800">
               <a:spcAft>
-                <a:spcPts val="600"/>
+                <a:spcPts val="400"/>
               </a:spcAft>
               <a:buSzPct val="100000"/>
               <a:buChar char="•"/>
@@ -14368,7 +14368,7 @@
           <a:p>
             <a:pPr algn="l" marL="177800" indent="-177800">
               <a:spcAft>
-                <a:spcPts val="600"/>
+                <a:spcPts val="400"/>
               </a:spcAft>
               <a:buSzPct val="100000"/>
               <a:buChar char="•"/>
@@ -14386,7 +14386,7 @@
           <a:p>
             <a:pPr algn="l" marL="177800" indent="-177800">
               <a:spcAft>
-                <a:spcPts val="600"/>
+                <a:spcPts val="400"/>
               </a:spcAft>
               <a:buSzPct val="100000"/>
               <a:buChar char="•"/>
@@ -14412,7 +14412,7 @@
         <p:spPr>
           <a:xfrm>
             <a:off x="8158277" y="1417320"/>
-            <a:ext cx="3576218" cy="3703320"/>
+            <a:ext cx="3576218" cy="3794760"/>
           </a:xfrm>
           <a:prstGeom prst="roundRect">
             <a:avLst>
@@ -14433,8 +14433,8 @@
         </p:nvSpPr>
         <p:spPr>
           <a:xfrm>
-            <a:off x="8386877" y="1645920"/>
-            <a:ext cx="640080" cy="640080"/>
+            <a:off x="8386877" y="1668780"/>
+            <a:ext cx="502920" cy="502920"/>
           </a:xfrm>
           <a:prstGeom prst="ellipse">
             <a:avLst/>
@@ -14461,8 +14461,8 @@
         </p:blipFill>
         <p:spPr>
           <a:xfrm>
-            <a:off x="8546897" y="1805940"/>
-            <a:ext cx="320040" cy="320040"/>
+            <a:off x="8512607" y="1794510"/>
+            <a:ext cx="251460" cy="251460"/>
           </a:xfrm>
           <a:prstGeom prst="rect">
             <a:avLst/>
@@ -14477,8 +14477,8 @@
         </p:nvSpPr>
         <p:spPr>
           <a:xfrm>
-            <a:off x="9209837" y="1645920"/>
-            <a:ext cx="2296058" cy="640080"/>
+            <a:off x="9072677" y="1645920"/>
+            <a:ext cx="2433218" cy="548640"/>
           </a:xfrm>
           <a:prstGeom prst="rect">
             <a:avLst/>
@@ -14494,7 +14494,7 @@
               <a:buNone/>
             </a:pPr>
             <a:r>
-              <a:rPr lang="en-US" sz="2000" b="1" dirty="0">
+              <a:rPr lang="en-US" sz="1800" b="1" dirty="0">
                 <a:solidFill>
                   <a:schemeClr val="tx2"/>
                 </a:solidFill>
@@ -14504,7 +14504,7 @@
               </a:rPr>
               <a:t>Cell</a:t>
             </a:r>
-            <a:endParaRPr lang="en-US" sz="2000" dirty="0"/>
+            <a:endParaRPr lang="en-US" sz="1800" dirty="0"/>
           </a:p>
         </p:txBody>
       </p:sp>
@@ -14516,8 +14516,8 @@
         </p:nvSpPr>
         <p:spPr>
           <a:xfrm>
-            <a:off x="8386877" y="2468880"/>
-            <a:ext cx="3119018" cy="2423160"/>
+            <a:off x="8386877" y="2286000"/>
+            <a:ext cx="3119018" cy="2834640"/>
           </a:xfrm>
           <a:prstGeom prst="rect">
             <a:avLst/>
@@ -14531,7 +14531,7 @@
           <a:p>
             <a:pPr algn="l" marL="177800" indent="-177800">
               <a:spcAft>
-                <a:spcPts val="600"/>
+                <a:spcPts val="400"/>
               </a:spcAft>
               <a:buSzPct val="100000"/>
               <a:buChar char="•"/>
@@ -14549,7 +14549,7 @@
           <a:p>
             <a:pPr algn="l" marL="177800" indent="-177800">
               <a:spcAft>
-                <a:spcPts val="600"/>
+                <a:spcPts val="400"/>
               </a:spcAft>
               <a:buSzPct val="100000"/>
               <a:buChar char="•"/>
@@ -14567,7 +14567,7 @@
           <a:p>
             <a:pPr algn="l" marL="177800" indent="-177800">
               <a:spcAft>
-                <a:spcPts val="600"/>
+                <a:spcPts val="400"/>
               </a:spcAft>
               <a:buSzPct val="100000"/>
               <a:buChar char="•"/>
@@ -15368,11 +15368,11 @@
         <p:spPr>
           <a:xfrm>
             <a:off x="457200" y="1417320"/>
-            <a:ext cx="5501488" cy="1868424"/>
+            <a:ext cx="5501488" cy="1943100"/>
           </a:xfrm>
           <a:prstGeom prst="roundRect">
             <a:avLst>
-              <a:gd name="adj" fmla="val 5873"/>
+              <a:gd name="adj" fmla="val 5647"/>
             </a:avLst>
           </a:prstGeom>
           <a:solidFill>
@@ -15394,7 +15394,7 @@
         </p:nvSpPr>
         <p:spPr>
           <a:xfrm>
-            <a:off x="640080" y="1600200"/>
+            <a:off x="594360" y="1554480"/>
             <a:ext cx="640080" cy="640080"/>
           </a:xfrm>
           <a:prstGeom prst="ellipse">
@@ -15422,7 +15422,7 @@
         </p:blipFill>
         <p:spPr>
           <a:xfrm>
-            <a:off x="800100" y="1760220"/>
+            <a:off x="754380" y="1714500"/>
             <a:ext cx="320040" cy="320040"/>
           </a:xfrm>
           <a:prstGeom prst="rect">
@@ -15438,8 +15438,8 @@
         </p:nvSpPr>
         <p:spPr>
           <a:xfrm>
-            <a:off x="1463040" y="1600200"/>
-            <a:ext cx="4312768" cy="1502664"/>
+            <a:off x="1417320" y="1554480"/>
+            <a:ext cx="4404208" cy="1668780"/>
           </a:xfrm>
           <a:prstGeom prst="rect">
             <a:avLst/>
@@ -15509,11 +15509,11 @@
         <p:spPr>
           <a:xfrm>
             <a:off x="6233008" y="1417320"/>
-            <a:ext cx="5501488" cy="1868424"/>
+            <a:ext cx="5501488" cy="1943100"/>
           </a:xfrm>
           <a:prstGeom prst="roundRect">
             <a:avLst>
-              <a:gd name="adj" fmla="val 5873"/>
+              <a:gd name="adj" fmla="val 5647"/>
             </a:avLst>
           </a:prstGeom>
           <a:solidFill>
@@ -15535,7 +15535,7 @@
         </p:nvSpPr>
         <p:spPr>
           <a:xfrm>
-            <a:off x="6415888" y="1600200"/>
+            <a:off x="6370168" y="1554480"/>
             <a:ext cx="640080" cy="640080"/>
           </a:xfrm>
           <a:prstGeom prst="ellipse">
@@ -15563,7 +15563,7 @@
         </p:blipFill>
         <p:spPr>
           <a:xfrm>
-            <a:off x="6575908" y="1760220"/>
+            <a:off x="6530188" y="1714500"/>
             <a:ext cx="320040" cy="320040"/>
           </a:xfrm>
           <a:prstGeom prst="rect">
@@ -15579,8 +15579,8 @@
         </p:nvSpPr>
         <p:spPr>
           <a:xfrm>
-            <a:off x="7238848" y="1600200"/>
-            <a:ext cx="4312768" cy="1502664"/>
+            <a:off x="7193128" y="1554480"/>
+            <a:ext cx="4404208" cy="1668780"/>
           </a:xfrm>
           <a:prstGeom prst="rect">
             <a:avLst/>
@@ -15649,12 +15649,12 @@
         </p:nvSpPr>
         <p:spPr>
           <a:xfrm>
-            <a:off x="457200" y="3560064"/>
-            <a:ext cx="5501488" cy="2142744"/>
+            <a:off x="457200" y="3543300"/>
+            <a:ext cx="5501488" cy="1943100"/>
           </a:xfrm>
           <a:prstGeom prst="roundRect">
             <a:avLst>
-              <a:gd name="adj" fmla="val 5121"/>
+              <a:gd name="adj" fmla="val 5647"/>
             </a:avLst>
           </a:prstGeom>
           <a:solidFill>
@@ -15676,7 +15676,7 @@
         </p:nvSpPr>
         <p:spPr>
           <a:xfrm>
-            <a:off x="640080" y="3742944"/>
+            <a:off x="594360" y="3680460"/>
             <a:ext cx="640080" cy="640080"/>
           </a:xfrm>
           <a:prstGeom prst="ellipse">
@@ -15704,7 +15704,7 @@
         </p:blipFill>
         <p:spPr>
           <a:xfrm>
-            <a:off x="800100" y="3902964"/>
+            <a:off x="754380" y="3840480"/>
             <a:ext cx="320040" cy="320040"/>
           </a:xfrm>
           <a:prstGeom prst="rect">
@@ -15720,8 +15720,8 @@
         </p:nvSpPr>
         <p:spPr>
           <a:xfrm>
-            <a:off x="1463040" y="3742944"/>
-            <a:ext cx="4312768" cy="1776984"/>
+            <a:off x="1417320" y="3680460"/>
+            <a:ext cx="4404208" cy="1668780"/>
           </a:xfrm>
           <a:prstGeom prst="rect">
             <a:avLst/>
@@ -15790,12 +15790,12 @@
         </p:nvSpPr>
         <p:spPr>
           <a:xfrm>
-            <a:off x="6233008" y="3560064"/>
-            <a:ext cx="5501488" cy="2142744"/>
+            <a:off x="6233008" y="3543300"/>
+            <a:ext cx="5501488" cy="1943100"/>
           </a:xfrm>
           <a:prstGeom prst="roundRect">
             <a:avLst>
-              <a:gd name="adj" fmla="val 5121"/>
+              <a:gd name="adj" fmla="val 5647"/>
             </a:avLst>
           </a:prstGeom>
           <a:solidFill>
@@ -15817,7 +15817,7 @@
         </p:nvSpPr>
         <p:spPr>
           <a:xfrm>
-            <a:off x="6415888" y="3742944"/>
+            <a:off x="6370168" y="3680460"/>
             <a:ext cx="640080" cy="640080"/>
           </a:xfrm>
           <a:prstGeom prst="ellipse">
@@ -15845,7 +15845,7 @@
         </p:blipFill>
         <p:spPr>
           <a:xfrm>
-            <a:off x="6575908" y="3902964"/>
+            <a:off x="6530188" y="3840480"/>
             <a:ext cx="320040" cy="320040"/>
           </a:xfrm>
           <a:prstGeom prst="rect">
@@ -15861,8 +15861,8 @@
         </p:nvSpPr>
         <p:spPr>
           <a:xfrm>
-            <a:off x="7238848" y="3742944"/>
-            <a:ext cx="4312768" cy="1776984"/>
+            <a:off x="7193128" y="3680460"/>
+            <a:ext cx="4404208" cy="1668780"/>
           </a:xfrm>
           <a:prstGeom prst="rect">
             <a:avLst/>
@@ -16079,7 +16079,7 @@
         <p:spPr>
           <a:xfrm>
             <a:off x="457200" y="1417320"/>
-            <a:ext cx="2407844" cy="2926080"/>
+            <a:ext cx="2407844" cy="2834640"/>
           </a:xfrm>
           <a:prstGeom prst="roundRect">
             <a:avLst>
@@ -16138,8 +16138,8 @@
         </p:nvSpPr>
         <p:spPr>
           <a:xfrm>
-            <a:off x="685800" y="2240280"/>
-            <a:ext cx="1950644" cy="320040"/>
+            <a:off x="1371600" y="1645920"/>
+            <a:ext cx="1264844" cy="502920"/>
           </a:xfrm>
           <a:prstGeom prst="rect">
             <a:avLst/>
@@ -16148,21 +16148,21 @@
           <a:ln/>
         </p:spPr>
         <p:txBody>
-          <a:bodyPr wrap="square" lIns="0" tIns="0" rIns="0" bIns="0" rtlCol="0" anchor="t"/>
+          <a:bodyPr wrap="square" lIns="0" tIns="0" rIns="0" bIns="0" rtlCol="0" anchor="ctr"/>
           <a:lstStyle/>
           <a:p>
             <a:pPr algn="l" indent="0" marL="0">
               <a:buNone/>
             </a:pPr>
             <a:r>
-              <a:rPr lang="en-US" sz="1800" b="1" dirty="0">
+              <a:rPr lang="en-US" sz="1600" b="1" dirty="0">
                 <a:solidFill>
                   <a:schemeClr val="tx2"/>
                 </a:solidFill>
               </a:rPr>
               <a:t>Mount</a:t>
             </a:r>
-            <a:endParaRPr lang="en-US" sz="1800" dirty="0"/>
+            <a:endParaRPr lang="en-US" sz="1600" dirty="0"/>
           </a:p>
         </p:txBody>
       </p:sp>
@@ -16174,8 +16174,8 @@
         </p:nvSpPr>
         <p:spPr>
           <a:xfrm>
-            <a:off x="685800" y="2560320"/>
-            <a:ext cx="1950644" cy="1554480"/>
+            <a:off x="685800" y="2240280"/>
+            <a:ext cx="1950644" cy="1783080"/>
           </a:xfrm>
           <a:prstGeom prst="rect">
             <a:avLst/>
@@ -16210,7 +16210,7 @@
         </p:nvSpPr>
         <p:spPr>
           <a:xfrm>
-            <a:off x="3025064" y="2697480"/>
+            <a:off x="3025064" y="2651760"/>
             <a:ext cx="228600" cy="365760"/>
           </a:xfrm>
           <a:prstGeom prst="chevron">
@@ -16231,7 +16231,7 @@
         <p:spPr>
           <a:xfrm>
             <a:off x="3413684" y="1417320"/>
-            <a:ext cx="2407844" cy="2926080"/>
+            <a:ext cx="2407844" cy="2834640"/>
           </a:xfrm>
           <a:prstGeom prst="roundRect">
             <a:avLst>
@@ -16290,8 +16290,8 @@
         </p:nvSpPr>
         <p:spPr>
           <a:xfrm>
-            <a:off x="3642284" y="2240280"/>
-            <a:ext cx="1950644" cy="320040"/>
+            <a:off x="4328084" y="1645920"/>
+            <a:ext cx="1264844" cy="502920"/>
           </a:xfrm>
           <a:prstGeom prst="rect">
             <a:avLst/>
@@ -16300,21 +16300,21 @@
           <a:ln/>
         </p:spPr>
         <p:txBody>
-          <a:bodyPr wrap="square" lIns="0" tIns="0" rIns="0" bIns="0" rtlCol="0" anchor="t"/>
+          <a:bodyPr wrap="square" lIns="0" tIns="0" rIns="0" bIns="0" rtlCol="0" anchor="ctr"/>
           <a:lstStyle/>
           <a:p>
             <a:pPr algn="l" indent="0" marL="0">
               <a:buNone/>
             </a:pPr>
             <a:r>
-              <a:rPr lang="en-US" sz="1800" b="1" dirty="0">
+              <a:rPr lang="en-US" sz="1600" b="1" dirty="0">
                 <a:solidFill>
                   <a:schemeClr val="tx2"/>
                 </a:solidFill>
               </a:rPr>
               <a:t>Jog</a:t>
             </a:r>
-            <a:endParaRPr lang="en-US" sz="1800" dirty="0"/>
+            <a:endParaRPr lang="en-US" sz="1600" dirty="0"/>
           </a:p>
         </p:txBody>
       </p:sp>
@@ -16326,8 +16326,8 @@
         </p:nvSpPr>
         <p:spPr>
           <a:xfrm>
-            <a:off x="3642284" y="2560320"/>
-            <a:ext cx="1950644" cy="1554480"/>
+            <a:off x="3642284" y="2240280"/>
+            <a:ext cx="1950644" cy="1783080"/>
           </a:xfrm>
           <a:prstGeom prst="rect">
             <a:avLst/>
@@ -16362,7 +16362,7 @@
         </p:nvSpPr>
         <p:spPr>
           <a:xfrm>
-            <a:off x="5981548" y="2697480"/>
+            <a:off x="5981548" y="2651760"/>
             <a:ext cx="228600" cy="365760"/>
           </a:xfrm>
           <a:prstGeom prst="chevron">
@@ -16383,7 +16383,7 @@
         <p:spPr>
           <a:xfrm>
             <a:off x="6370168" y="1417320"/>
-            <a:ext cx="2407844" cy="2926080"/>
+            <a:ext cx="2407844" cy="2834640"/>
           </a:xfrm>
           <a:prstGeom prst="roundRect">
             <a:avLst>
@@ -16442,8 +16442,8 @@
         </p:nvSpPr>
         <p:spPr>
           <a:xfrm>
-            <a:off x="6598768" y="2240280"/>
-            <a:ext cx="1950644" cy="320040"/>
+            <a:off x="7284568" y="1645920"/>
+            <a:ext cx="1264844" cy="502920"/>
           </a:xfrm>
           <a:prstGeom prst="rect">
             <a:avLst/>
@@ -16452,21 +16452,21 @@
           <a:ln/>
         </p:spPr>
         <p:txBody>
-          <a:bodyPr wrap="square" lIns="0" tIns="0" rIns="0" bIns="0" rtlCol="0" anchor="t"/>
+          <a:bodyPr wrap="square" lIns="0" tIns="0" rIns="0" bIns="0" rtlCol="0" anchor="ctr"/>
           <a:lstStyle/>
           <a:p>
             <a:pPr algn="l" indent="0" marL="0">
               <a:buNone/>
             </a:pPr>
             <a:r>
-              <a:rPr lang="en-US" sz="1800" b="1" dirty="0">
+              <a:rPr lang="en-US" sz="1600" b="1" dirty="0">
                 <a:solidFill>
                   <a:schemeClr val="tx2"/>
                 </a:solidFill>
               </a:rPr>
               <a:t>Capture</a:t>
             </a:r>
-            <a:endParaRPr lang="en-US" sz="1800" dirty="0"/>
+            <a:endParaRPr lang="en-US" sz="1600" dirty="0"/>
           </a:p>
         </p:txBody>
       </p:sp>
@@ -16478,8 +16478,8 @@
         </p:nvSpPr>
         <p:spPr>
           <a:xfrm>
-            <a:off x="6598768" y="2560320"/>
-            <a:ext cx="1950644" cy="1554480"/>
+            <a:off x="6598768" y="2240280"/>
+            <a:ext cx="1950644" cy="1783080"/>
           </a:xfrm>
           <a:prstGeom prst="rect">
             <a:avLst/>
@@ -16514,7 +16514,7 @@
         </p:nvSpPr>
         <p:spPr>
           <a:xfrm>
-            <a:off x="8938031" y="2697480"/>
+            <a:off x="8938031" y="2651760"/>
             <a:ext cx="228600" cy="365760"/>
           </a:xfrm>
           <a:prstGeom prst="chevron">
@@ -16535,7 +16535,7 @@
         <p:spPr>
           <a:xfrm>
             <a:off x="9326651" y="1417320"/>
-            <a:ext cx="2407844" cy="2926080"/>
+            <a:ext cx="2407844" cy="2834640"/>
           </a:xfrm>
           <a:prstGeom prst="roundRect">
             <a:avLst>
@@ -16594,8 +16594,8 @@
         </p:nvSpPr>
         <p:spPr>
           <a:xfrm>
-            <a:off x="9555251" y="2240280"/>
-            <a:ext cx="1950644" cy="320040"/>
+            <a:off x="10241051" y="1645920"/>
+            <a:ext cx="1264844" cy="502920"/>
           </a:xfrm>
           <a:prstGeom prst="rect">
             <a:avLst/>
@@ -16604,21 +16604,21 @@
           <a:ln/>
         </p:spPr>
         <p:txBody>
-          <a:bodyPr wrap="square" lIns="0" tIns="0" rIns="0" bIns="0" rtlCol="0" anchor="t"/>
+          <a:bodyPr wrap="square" lIns="0" tIns="0" rIns="0" bIns="0" rtlCol="0" anchor="ctr"/>
           <a:lstStyle/>
           <a:p>
             <a:pPr algn="l" indent="0" marL="0">
               <a:buNone/>
             </a:pPr>
             <a:r>
-              <a:rPr lang="en-US" sz="1800" b="1" dirty="0">
+              <a:rPr lang="en-US" sz="1600" b="1" dirty="0">
                 <a:solidFill>
                   <a:schemeClr val="tx2"/>
                 </a:solidFill>
               </a:rPr>
               <a:t>Solve (engineer)</a:t>
             </a:r>
-            <a:endParaRPr lang="en-US" sz="1800" dirty="0"/>
+            <a:endParaRPr lang="en-US" sz="1600" dirty="0"/>
           </a:p>
         </p:txBody>
       </p:sp>
@@ -16630,8 +16630,8 @@
         </p:nvSpPr>
         <p:spPr>
           <a:xfrm>
-            <a:off x="9555251" y="2560320"/>
-            <a:ext cx="1950644" cy="1554480"/>
+            <a:off x="9555251" y="2240280"/>
+            <a:ext cx="1950644" cy="1783080"/>
           </a:xfrm>
           <a:prstGeom prst="rect">
             <a:avLst/>
@@ -16666,12 +16666,12 @@
         </p:nvSpPr>
         <p:spPr>
           <a:xfrm>
-            <a:off x="457200" y="4617720"/>
-            <a:ext cx="2407844" cy="1508760"/>
+            <a:off x="457200" y="4526280"/>
+            <a:ext cx="2407844" cy="1600200"/>
           </a:xfrm>
           <a:prstGeom prst="roundRect">
             <a:avLst>
-              <a:gd name="adj" fmla="val 7273"/>
+              <a:gd name="adj" fmla="val 6857"/>
             </a:avLst>
           </a:prstGeom>
           <a:solidFill>
@@ -16688,7 +16688,7 @@
         </p:nvSpPr>
         <p:spPr>
           <a:xfrm>
-            <a:off x="685800" y="4823460"/>
+            <a:off x="685800" y="4617720"/>
             <a:ext cx="1950644" cy="548640"/>
           </a:xfrm>
           <a:prstGeom prst="rect">
@@ -16727,8 +16727,8 @@
         </p:nvSpPr>
         <p:spPr>
           <a:xfrm>
-            <a:off x="685800" y="5372100"/>
-            <a:ext cx="1950644" cy="548640"/>
+            <a:off x="685800" y="5166360"/>
+            <a:ext cx="1950644" cy="868680"/>
           </a:xfrm>
           <a:prstGeom prst="rect">
             <a:avLst/>
@@ -16763,12 +16763,12 @@
         </p:nvSpPr>
         <p:spPr>
           <a:xfrm>
-            <a:off x="3139364" y="4617720"/>
-            <a:ext cx="2407844" cy="1508760"/>
+            <a:off x="3139364" y="4526280"/>
+            <a:ext cx="2407844" cy="1600200"/>
           </a:xfrm>
           <a:prstGeom prst="roundRect">
             <a:avLst>
-              <a:gd name="adj" fmla="val 7273"/>
+              <a:gd name="adj" fmla="val 6857"/>
             </a:avLst>
           </a:prstGeom>
           <a:solidFill>
@@ -16785,7 +16785,7 @@
         </p:nvSpPr>
         <p:spPr>
           <a:xfrm>
-            <a:off x="3367964" y="4823460"/>
+            <a:off x="3367964" y="4617720"/>
             <a:ext cx="1950644" cy="548640"/>
           </a:xfrm>
           <a:prstGeom prst="rect">
@@ -16824,8 +16824,8 @@
         </p:nvSpPr>
         <p:spPr>
           <a:xfrm>
-            <a:off x="3367964" y="5372100"/>
-            <a:ext cx="1950644" cy="548640"/>
+            <a:off x="3367964" y="5166360"/>
+            <a:ext cx="1950644" cy="868680"/>
           </a:xfrm>
           <a:prstGeom prst="rect">
             <a:avLst/>
@@ -16860,12 +16860,12 @@
         </p:nvSpPr>
         <p:spPr>
           <a:xfrm>
-            <a:off x="5821528" y="4617720"/>
-            <a:ext cx="5912968" cy="1508760"/>
+            <a:off x="5821528" y="4526280"/>
+            <a:ext cx="5912968" cy="1600200"/>
           </a:xfrm>
           <a:prstGeom prst="roundRect">
             <a:avLst>
-              <a:gd name="adj" fmla="val 7273"/>
+              <a:gd name="adj" fmla="val 6857"/>
             </a:avLst>
           </a:prstGeom>
           <a:solidFill>
@@ -16887,7 +16887,7 @@
         </p:nvSpPr>
         <p:spPr>
           <a:xfrm>
-            <a:off x="6050128" y="5052060"/>
+            <a:off x="6050128" y="5006340"/>
             <a:ext cx="640080" cy="640080"/>
           </a:xfrm>
           <a:prstGeom prst="ellipse">
@@ -16915,7 +16915,7 @@
         </p:blipFill>
         <p:spPr>
           <a:xfrm>
-            <a:off x="6210148" y="5212080"/>
+            <a:off x="6210148" y="5166360"/>
             <a:ext cx="320040" cy="320040"/>
           </a:xfrm>
           <a:prstGeom prst="rect">
@@ -16931,8 +16931,8 @@
         </p:nvSpPr>
         <p:spPr>
           <a:xfrm>
-            <a:off x="6873088" y="4617720"/>
-            <a:ext cx="4632808" cy="1508760"/>
+            <a:off x="6873088" y="4526280"/>
+            <a:ext cx="4632808" cy="1600200"/>
           </a:xfrm>
           <a:prstGeom prst="rect">
             <a:avLst/>

</xml_diff>

<commit_message>
Two decks (procurement and build; test procedure and robot program), generator, assets, checks, renders; consistency-pass report
Decks built by docs/presentations/build/make_perf_deck.js from the two content files (17 and 20
slides, speaker notes on every slide, no status slides); assets from the procedure figures and the
drawings; content check (every string on its slide, notes equal, cost figures against costs.py),
layout check and package validation pass; renders under archive/qa_renders. The consistency pass
of the procedure against both decks is in docs/presentations/archive/consistency_pass_2026-10-08.md
(5 conflicts, 4 gaps; reported, not edited).

Co-Authored-By: Claude Fable 5.1 <noreply@anthropic.com>
Claude-Session: https://claude.ai/code/session_01ERsPi9xhFu3U1nLCkBXPjN
</commit_message>
<xml_diff>
--- a/docs/presentations/vsx3000_test_procedure.pptx
+++ b/docs/presentations/vsx3000_test_procedure.pptx
@@ -126,7 +126,7 @@
   <p:extLst>
     <p:ext uri="{521415D9-36F7-43E2-AB2F-B90AF26B5E84}">
       <p14:sectionLst xmlns:p14="http://schemas.microsoft.com/office/powerpoint/2010/main">
-        <p14:section name="Introduction" id="{3b354e0a-7989-4801-9cd3-def413595b05}">
+        <p14:section name="Introduction" id="{1253a9a5-19fa-64fb-08e1-f32be860ce05}">
           <p14:sldIdLst>
             <p14:sldId id="256"/>
             <p14:sldId id="257"/>
@@ -135,7 +135,7 @@
             <p14:sldId id="260"/>
           </p14:sldIdLst>
         </p14:section>
-        <p14:section name="Setup" id="{ee880393-b860-f94a-28c3-e118731315f5}">
+        <p14:section name="Setup" id="{bae6aeb9-a127-926d-55da-bd566d35ca28}">
           <p14:sldIdLst>
             <p14:sldId id="261"/>
             <p14:sldId id="262"/>
@@ -143,7 +143,7 @@
             <p14:sldId id="264"/>
           </p14:sldIdLst>
         </p14:section>
-        <p14:section name="Capture" id="{50305cac-f6a5-9fff-61f0-11df207f671a}">
+        <p14:section name="Capture" id="{625b47eb-9f4b-4ce1-2d7a-30f1fd95fad7}">
           <p14:sldIdLst>
             <p14:sldId id="265"/>
             <p14:sldId id="266"/>
@@ -155,12 +155,12 @@
             <p14:sldId id="272"/>
           </p14:sldIdLst>
         </p14:section>
-        <p14:section name="Checks" id="{7e81be1c-866d-d82a-d46d-12fe25f2d19a}">
+        <p14:section name="Checks" id="{cbeaae15-ec7c-3557-3aa4-c5cce452309f}">
           <p14:sldIdLst>
             <p14:sldId id="273"/>
           </p14:sldIdLst>
         </p14:section>
-        <p14:section name="Wrap-up" id="{f341a2df-2708-aaa4-a7d0-ec3b9e075216}">
+        <p14:section name="Wrap-up" id="{e8bc4a22-ff93-3d68-ef0d-588e6067cae6}">
           <p14:sldIdLst>
             <p14:sldId id="274"/>
             <p14:sldId id="275"/>
@@ -4859,7 +4859,7 @@
                   <a:schemeClr val="tx1"/>
                 </a:solidFill>
               </a:rPr>
-              <a:t>Trigger the row's frames through the capture software, named &lt;proc&gt;_&lt;target&gt;_G&lt;gap&gt;_Z&lt;zzzz&gt;_F&lt;field&gt;_P&lt;pose&gt;_f&lt;frame&gt;.mc</a:t>
+              <a:t>Trigger the row's frames through the capture software, named from the row by the rule of section 5 (procedure, target, gap, station, field, pose, frame; the example is on the next slide)</a:t>
             </a:r>
             <a:endParaRPr lang="en-US" sz="1400" dirty="0"/>
           </a:p>
@@ -6828,8 +6828,8 @@
         </p:blipFill>
         <p:spPr>
           <a:xfrm>
-            <a:off x="457200" y="2933114"/>
-            <a:ext cx="4846320" cy="1677572"/>
+            <a:off x="457200" y="2698388"/>
+            <a:ext cx="6202512" cy="2147024"/>
           </a:xfrm>
           <a:prstGeom prst="rect">
             <a:avLst/>
@@ -6844,8 +6844,8 @@
         </p:nvSpPr>
         <p:spPr>
           <a:xfrm>
-            <a:off x="457200" y="2933114"/>
-            <a:ext cx="4846320" cy="1677572"/>
+            <a:off x="457200" y="2698388"/>
+            <a:ext cx="6202512" cy="2147024"/>
           </a:xfrm>
           <a:prstGeom prst="rect">
             <a:avLst/>
@@ -6866,12 +6866,12 @@
         </p:nvSpPr>
         <p:spPr>
           <a:xfrm>
-            <a:off x="5577840" y="1417320"/>
-            <a:ext cx="6156655" cy="718718"/>
+            <a:off x="6934032" y="1417320"/>
+            <a:ext cx="4800463" cy="792480"/>
           </a:xfrm>
           <a:prstGeom prst="roundRect">
             <a:avLst>
-              <a:gd name="adj" fmla="val 15267"/>
+              <a:gd name="adj" fmla="val 13846"/>
             </a:avLst>
           </a:prstGeom>
           <a:solidFill>
@@ -6888,7 +6888,7 @@
         </p:nvSpPr>
         <p:spPr>
           <a:xfrm>
-            <a:off x="5692140" y="1525219"/>
+            <a:off x="7048332" y="1562100"/>
             <a:ext cx="502920" cy="502920"/>
           </a:xfrm>
           <a:prstGeom prst="ellipse">
@@ -6926,8 +6926,8 @@
         </p:nvSpPr>
         <p:spPr>
           <a:xfrm>
-            <a:off x="6377940" y="1417320"/>
-            <a:ext cx="5242255" cy="718718"/>
+            <a:off x="7734132" y="1417320"/>
+            <a:ext cx="3886063" cy="792480"/>
           </a:xfrm>
           <a:prstGeom prst="rect">
             <a:avLst/>
@@ -6962,12 +6962,12 @@
         </p:nvSpPr>
         <p:spPr>
           <a:xfrm>
-            <a:off x="5577840" y="2318918"/>
-            <a:ext cx="6156655" cy="910742"/>
+            <a:off x="6934032" y="2337816"/>
+            <a:ext cx="4800463" cy="1005840"/>
           </a:xfrm>
           <a:prstGeom prst="roundRect">
             <a:avLst>
-              <a:gd name="adj" fmla="val 12048"/>
+              <a:gd name="adj" fmla="val 10909"/>
             </a:avLst>
           </a:prstGeom>
           <a:solidFill>
@@ -6984,7 +6984,7 @@
         </p:nvSpPr>
         <p:spPr>
           <a:xfrm>
-            <a:off x="5692140" y="2522830"/>
+            <a:off x="7048332" y="2589276"/>
             <a:ext cx="502920" cy="502920"/>
           </a:xfrm>
           <a:prstGeom prst="ellipse">
@@ -7022,8 +7022,8 @@
         </p:nvSpPr>
         <p:spPr>
           <a:xfrm>
-            <a:off x="6377940" y="2318918"/>
-            <a:ext cx="5242255" cy="910742"/>
+            <a:off x="7734132" y="2337816"/>
+            <a:ext cx="3886063" cy="1005840"/>
           </a:xfrm>
           <a:prstGeom prst="rect">
             <a:avLst/>
@@ -7058,12 +7058,12 @@
         </p:nvSpPr>
         <p:spPr>
           <a:xfrm>
-            <a:off x="5577840" y="3412541"/>
-            <a:ext cx="6156655" cy="910742"/>
+            <a:off x="6934032" y="3471672"/>
+            <a:ext cx="4800463" cy="1005840"/>
           </a:xfrm>
           <a:prstGeom prst="roundRect">
             <a:avLst>
-              <a:gd name="adj" fmla="val 12048"/>
+              <a:gd name="adj" fmla="val 10909"/>
             </a:avLst>
           </a:prstGeom>
           <a:solidFill>
@@ -7080,7 +7080,7 @@
         </p:nvSpPr>
         <p:spPr>
           <a:xfrm>
-            <a:off x="5692140" y="3616452"/>
+            <a:off x="7048332" y="3723132"/>
             <a:ext cx="502920" cy="502920"/>
           </a:xfrm>
           <a:prstGeom prst="ellipse">
@@ -7118,8 +7118,8 @@
         </p:nvSpPr>
         <p:spPr>
           <a:xfrm>
-            <a:off x="6377940" y="3412541"/>
-            <a:ext cx="5242255" cy="910742"/>
+            <a:off x="7734132" y="3471672"/>
+            <a:ext cx="3886063" cy="1005840"/>
           </a:xfrm>
           <a:prstGeom prst="rect">
             <a:avLst/>
@@ -7154,12 +7154,12 @@
         </p:nvSpPr>
         <p:spPr>
           <a:xfrm>
-            <a:off x="5577840" y="4506163"/>
-            <a:ext cx="6156655" cy="718718"/>
+            <a:off x="6934032" y="4605528"/>
+            <a:ext cx="4800463" cy="600456"/>
           </a:xfrm>
           <a:prstGeom prst="roundRect">
             <a:avLst>
-              <a:gd name="adj" fmla="val 15267"/>
+              <a:gd name="adj" fmla="val 18274"/>
             </a:avLst>
           </a:prstGeom>
           <a:solidFill>
@@ -7176,7 +7176,7 @@
         </p:nvSpPr>
         <p:spPr>
           <a:xfrm>
-            <a:off x="5692140" y="4614062"/>
+            <a:off x="7048332" y="4654296"/>
             <a:ext cx="502920" cy="502920"/>
           </a:xfrm>
           <a:prstGeom prst="ellipse">
@@ -7214,8 +7214,8 @@
         </p:nvSpPr>
         <p:spPr>
           <a:xfrm>
-            <a:off x="6377940" y="4506163"/>
-            <a:ext cx="5242255" cy="718718"/>
+            <a:off x="7734132" y="4605528"/>
+            <a:ext cx="3886063" cy="600456"/>
           </a:xfrm>
           <a:prstGeom prst="rect">
             <a:avLst/>
@@ -7250,12 +7250,12 @@
         </p:nvSpPr>
         <p:spPr>
           <a:xfrm>
-            <a:off x="5577840" y="5407762"/>
-            <a:ext cx="6156655" cy="718718"/>
+            <a:off x="6934032" y="5334000"/>
+            <a:ext cx="4800463" cy="792480"/>
           </a:xfrm>
           <a:prstGeom prst="roundRect">
             <a:avLst>
-              <a:gd name="adj" fmla="val 15267"/>
+              <a:gd name="adj" fmla="val 13846"/>
             </a:avLst>
           </a:prstGeom>
           <a:solidFill>
@@ -7272,7 +7272,7 @@
         </p:nvSpPr>
         <p:spPr>
           <a:xfrm>
-            <a:off x="5692140" y="5515661"/>
+            <a:off x="7048332" y="5478780"/>
             <a:ext cx="502920" cy="502920"/>
           </a:xfrm>
           <a:prstGeom prst="ellipse">
@@ -7310,8 +7310,8 @@
         </p:nvSpPr>
         <p:spPr>
           <a:xfrm>
-            <a:off x="6377940" y="5407762"/>
-            <a:ext cx="5242255" cy="718718"/>
+            <a:off x="7734132" y="5334000"/>
+            <a:ext cx="3886063" cy="792480"/>
           </a:xfrm>
           <a:prstGeom prst="rect">
             <a:avLst/>

</xml_diff>

<commit_message>
Consistency-pass fixes: T5 spigot on the edge bracket, chamfer worked value aligned with the specification, deck gap and flatness wording, 1f fit check and witness line
Co-Authored-By: Claude Fable 5.1 <noreply@anthropic.com>
Claude-Session: https://claude.ai/code/session_01ERsPi9xhFu3U1nLCkBXPjN
</commit_message>
<xml_diff>
--- a/docs/presentations/vsx3000_test_procedure.pptx
+++ b/docs/presentations/vsx3000_test_procedure.pptx
@@ -126,7 +126,7 @@
   <p:extLst>
     <p:ext uri="{521415D9-36F7-43E2-AB2F-B90AF26B5E84}">
       <p14:sectionLst xmlns:p14="http://schemas.microsoft.com/office/powerpoint/2010/main">
-        <p14:section name="Introduction" id="{1253a9a5-19fa-64fb-08e1-f32be860ce05}">
+        <p14:section name="Introduction" id="{f1bdcf05-a819-6d5e-0c9a-b21ea73bf511}">
           <p14:sldIdLst>
             <p14:sldId id="256"/>
             <p14:sldId id="257"/>
@@ -135,7 +135,7 @@
             <p14:sldId id="260"/>
           </p14:sldIdLst>
         </p14:section>
-        <p14:section name="Setup" id="{bae6aeb9-a127-926d-55da-bd566d35ca28}">
+        <p14:section name="Setup" id="{d1e57a67-64f3-9762-7f55-f456370301e8}">
           <p14:sldIdLst>
             <p14:sldId id="261"/>
             <p14:sldId id="262"/>
@@ -143,7 +143,7 @@
             <p14:sldId id="264"/>
           </p14:sldIdLst>
         </p14:section>
-        <p14:section name="Capture" id="{625b47eb-9f4b-4ce1-2d7a-30f1fd95fad7}">
+        <p14:section name="Capture" id="{e3694b31-d332-bc0e-e88f-5ff94e0f10cc}">
           <p14:sldIdLst>
             <p14:sldId id="265"/>
             <p14:sldId id="266"/>
@@ -155,12 +155,12 @@
             <p14:sldId id="272"/>
           </p14:sldIdLst>
         </p14:section>
-        <p14:section name="Checks" id="{cbeaae15-ec7c-3557-3aa4-c5cce452309f}">
+        <p14:section name="Checks" id="{f1cc29d5-fe59-58b9-6c50-61ed5b9620ed}">
           <p14:sldIdLst>
             <p14:sldId id="273"/>
           </p14:sldIdLst>
         </p14:section>
-        <p14:section name="Wrap-up" id="{e8bc4a22-ff93-3d68-ef0d-588e6067cae6}">
+        <p14:section name="Wrap-up" id="{5eb43848-f8d3-91aa-0e6c-c4dfc9c640c7}">
           <p14:sldIdLst>
             <p14:sldId id="274"/>
             <p14:sldId id="275"/>

</xml_diff>

<commit_message>
Capture check: limits scale with depth and with each fit's own tilt precision (correlation-aware); field-fit sentence corrected in both documents; dry-run findings logged
check_captures: residual and offset limits grow as (Z / 800 mm)^2 beyond the reference station; the
tilt limit is max(2 deg, 4 standard errors of the fitted tilt), the standard error using an effective
pixel count from the residual autocorrelation; tilts the fit cannot resolve to 10 deg are reported as
not testable. A clean synthetic session (367 poses, full resolution) now passes with no flags, and a
50 mm registration error is still caught (tests/test_check_limits.py; 260 tests pass). Procedure
Section 12 and appendix B, the test-procedure deck's checks slide, specification rev 125 (Section 3.2)
and the procedure's Section 2 updated; gates pass.

Co-Authored-By: Claude Fable 5.1 <noreply@anthropic.com>
Claude-Session: https://claude.ai/code/session_01ERsPi9xhFu3U1nLCkBXPjN
</commit_message>
<xml_diff>
--- a/docs/presentations/vsx3000_test_procedure.pptx
+++ b/docs/presentations/vsx3000_test_procedure.pptx
@@ -126,7 +126,7 @@
   <p:extLst>
     <p:ext uri="{521415D9-36F7-43E2-AB2F-B90AF26B5E84}">
       <p14:sectionLst xmlns:p14="http://schemas.microsoft.com/office/powerpoint/2010/main">
-        <p14:section name="Introduction" id="{f1bdcf05-a819-6d5e-0c9a-b21ea73bf511}">
+        <p14:section name="Introduction" id="{177f061a-f111-3e8b-390d-a96fa3e1e41e}">
           <p14:sldIdLst>
             <p14:sldId id="256"/>
             <p14:sldId id="257"/>
@@ -135,7 +135,7 @@
             <p14:sldId id="260"/>
           </p14:sldIdLst>
         </p14:section>
-        <p14:section name="Setup" id="{d1e57a67-64f3-9762-7f55-f456370301e8}">
+        <p14:section name="Setup" id="{d87bd70f-8e92-4da3-7b63-4fe4e4891f35}">
           <p14:sldIdLst>
             <p14:sldId id="261"/>
             <p14:sldId id="262"/>
@@ -143,7 +143,7 @@
             <p14:sldId id="264"/>
           </p14:sldIdLst>
         </p14:section>
-        <p14:section name="Capture" id="{e3694b31-d332-bc0e-e88f-5ff94e0f10cc}">
+        <p14:section name="Capture" id="{c5137563-1dfa-42e8-11ce-ff0bc213407f}">
           <p14:sldIdLst>
             <p14:sldId id="265"/>
             <p14:sldId id="266"/>
@@ -155,12 +155,12 @@
             <p14:sldId id="272"/>
           </p14:sldIdLst>
         </p14:section>
-        <p14:section name="Checks" id="{f1cc29d5-fe59-58b9-6c50-61ed5b9620ed}">
+        <p14:section name="Checks" id="{93a0deb6-8f53-1772-692c-f96bac0adb04}">
           <p14:sldIdLst>
             <p14:sldId id="273"/>
           </p14:sldIdLst>
         </p14:section>
-        <p14:section name="Wrap-up" id="{5eb43848-f8d3-91aa-0e6c-c4dfc9c640c7}">
+        <p14:section name="Wrap-up" id="{c7e87804-2855-29d5-13e4-f12f32f4c7b8}">
           <p14:sldIdLst>
             <p14:sldId id="274"/>
             <p14:sldId id="275"/>
@@ -1362,7 +1362,7 @@
           <a:p>
             <a:r>
               <a:rPr lang="en-US" dirty="0"/>
-              <a:t>Procedure section 12. Run the quick check as soon as a series is complete, while the robot and targets are still set up, so that a flagged pose can be re-captured without a re-mount. The same tool does the mount check (--mount-check) and the post check of series D (--pilot 800). Its limits are options listed in appendix B.</a:t>
+              <a:t>Procedure section 12. Run the quick check as soon as a series is complete, while the robot and targets are still set up, so that a flagged pose can be re-captured without a re-mount. The same tool does the mount check (--mount-check) and the post check of series D (--pilot 800). Its limits are options listed in appendix B. The limits scale with distance and with each fit's own precision (procedure section 12), so single frames at the far stations are not flagged for their noise; a clean synthetic session passes the check with no flags.</a:t>
             </a:r>
             <a:endParaRPr lang="en-US" dirty="0"/>
           </a:p>
@@ -9467,7 +9467,7 @@
                   <a:schemeClr val="tx1"/>
                 </a:solidFill>
               </a:rPr>
-              <a:t>A wrongly classified plane, a wrong pose, a wrong registration or a target that moved; the limits are loose on purpose</a:t>
+              <a:t>A wrongly classified plane, a wrong pose, a wrong registration or a target that moved; the limits are loose on purpose and grow with distance beyond 800 mm</a:t>
             </a:r>
             <a:endParaRPr lang="en-US" sz="1600" dirty="0"/>
           </a:p>
@@ -9594,7 +9594,7 @@
                   <a:schemeClr val="accent1"/>
                 </a:solidFill>
               </a:rPr>
-              <a:t>more than 2 degrees</a:t>
+              <a:t>more than 2 degrees, or more than the fit can resolve</a:t>
             </a:r>
             <a:endParaRPr lang="en-US" sz="1600" dirty="0"/>
           </a:p>
@@ -9608,7 +9608,7 @@
                   <a:schemeClr val="tx1"/>
                 </a:solidFill>
               </a:rPr>
-              <a:t>A tilted mount or a wrong pose</a:t>
+              <a:t>A tilted mount or a wrong pose; where the fit cannot resolve 10 degrees the line says "tilt not testable"</a:t>
             </a:r>
             <a:endParaRPr lang="en-US" sz="1600" dirty="0"/>
           </a:p>

</xml_diff>